<commit_message>
Fix leader_id constraint and team creation flow
</commit_message>
<xml_diff>
--- a/src/assets/PPT/Hackathon 2027.pptx
+++ b/src/assets/PPT/Hackathon 2027.pptx
@@ -1,38 +1,39 @@
 
 <file path=ppt/presentation.xml><?xml version="1.0" encoding="utf-8"?>
-<p:presentation xmlns:a="http://schemas.openxmlformats.org/drawingml/2006/main" xmlns:r="http://schemas.openxmlformats.org/officeDocument/2006/relationships" xmlns:p="http://schemas.openxmlformats.org/presentationml/2006/main" saveSubsetFonts="1" embedTrueTypeFonts="true">
+<p:presentation xmlns:a="http://schemas.openxmlformats.org/drawingml/2006/main" xmlns:r="http://schemas.openxmlformats.org/officeDocument/2006/relationships" xmlns:p="http://schemas.openxmlformats.org/presentationml/2006/main" embedTrueTypeFonts="1" saveSubsetFonts="1">
   <p:sldMasterIdLst>
     <p:sldMasterId id="2147483648" r:id="rId1"/>
   </p:sldMasterIdLst>
   <p:notesMasterIdLst>
-    <p:notesMasterId r:id="rId12"/>
+    <p:notesMasterId r:id="rId8"/>
   </p:notesMasterIdLst>
   <p:sldIdLst>
-    <p:sldId id="256" r:id="rId6"/>
-    <p:sldId id="257" r:id="rId7"/>
-    <p:sldId id="258" r:id="rId8"/>
-    <p:sldId id="259" r:id="rId9"/>
-    <p:sldId id="260" r:id="rId10"/>
-    <p:sldId id="261" r:id="rId11"/>
+    <p:sldId id="256" r:id="rId2"/>
+    <p:sldId id="257" r:id="rId3"/>
+    <p:sldId id="258" r:id="rId4"/>
+    <p:sldId id="259" r:id="rId5"/>
+    <p:sldId id="260" r:id="rId6"/>
+    <p:sldId id="261" r:id="rId7"/>
   </p:sldIdLst>
   <p:sldSz cx="18288000" cy="10287000"/>
   <p:notesSz cx="6858000" cy="9144000"/>
   <p:embeddedFontLst>
     <p:embeddedFont>
-      <p:font typeface="Cambria" charset="1" panose="02040503050406030204"/>
-      <p:regular r:id="rId15"/>
+      <p:font typeface="Arial Bold" panose="020B0704020202020204" pitchFamily="34" charset="0"/>
+      <p:regular r:id="rId9"/>
+      <p:bold r:id="rId10"/>
     </p:embeddedFont>
     <p:embeddedFont>
-      <p:font typeface="Cambria Bold" charset="1" panose="02040803050406030204"/>
-      <p:regular r:id="rId16"/>
+      <p:font typeface="Cambria" panose="02040503050406030204" pitchFamily="18" charset="0"/>
+      <p:regular r:id="rId11"/>
+      <p:bold r:id="rId12"/>
+      <p:italic r:id="rId13"/>
+      <p:boldItalic r:id="rId14"/>
     </p:embeddedFont>
     <p:embeddedFont>
-      <p:font typeface="Times New Roman" charset="1" panose="02020603050405020304"/>
-      <p:regular r:id="rId18"/>
-    </p:embeddedFont>
-    <p:embeddedFont>
-      <p:font typeface="Arial Bold" charset="1" panose="020B0704020202020204"/>
-      <p:regular r:id="rId21"/>
+      <p:font typeface="Cambria Bold" panose="02040803050406030204" pitchFamily="18" charset="0"/>
+      <p:regular r:id="rId15"/>
+      <p:bold r:id="rId16"/>
     </p:embeddedFont>
   </p:embeddedFontLst>
   <p:defaultTextStyle>
@@ -130,6 +131,22 @@
       </a:defRPr>
     </a:lvl9pPr>
   </p:defaultTextStyle>
+  <p:extLst>
+    <p:ext uri="{EFAFB233-063F-42B5-8137-9DF3F51BA10A}">
+      <p15:sldGuideLst xmlns:p15="http://schemas.microsoft.com/office/powerpoint/2012/main">
+        <p15:guide id="1" orient="horz" pos="2160">
+          <p15:clr>
+            <a:srgbClr val="A4A3A4"/>
+          </p15:clr>
+        </p15:guide>
+        <p15:guide id="2" pos="2880">
+          <p15:clr>
+            <a:srgbClr val="A4A3A4"/>
+          </p15:clr>
+        </p15:guide>
+      </p15:sldGuideLst>
+    </p:ext>
+  </p:extLst>
 </p:presentation>
 </file>
 
@@ -215,7 +232,7 @@
           <a:p>
             <a:fld id="{B7268E1E-0E44-426D-905E-8AD9B19D2182}" type="datetimeFigureOut">
               <a:rPr lang="cs-CZ" smtClean="0"/>
-              <a:t>1.7.2013</a:t>
+              <a:t>05.10.2026</a:t>
             </a:fld>
             <a:endParaRPr lang="cs-CZ"/>
           </a:p>
@@ -279,35 +296,35 @@
           <a:p>
             <a:pPr lvl="0"/>
             <a:r>
-              <a:rPr lang="en-US" smtClean="0"/>
+              <a:rPr lang="en-US"/>
               <a:t>Click to edit Master text styles</a:t>
             </a:r>
           </a:p>
           <a:p>
             <a:pPr lvl="1"/>
             <a:r>
-              <a:rPr lang="en-US" smtClean="0"/>
+              <a:rPr lang="en-US"/>
               <a:t>Second level</a:t>
             </a:r>
           </a:p>
           <a:p>
             <a:pPr lvl="2"/>
             <a:r>
-              <a:rPr lang="en-US" smtClean="0"/>
+              <a:rPr lang="en-US"/>
               <a:t>Third level</a:t>
             </a:r>
           </a:p>
           <a:p>
             <a:pPr lvl="3"/>
             <a:r>
-              <a:rPr lang="en-US" smtClean="0"/>
+              <a:rPr lang="en-US"/>
               <a:t>Fourth level</a:t>
             </a:r>
           </a:p>
           <a:p>
             <a:pPr lvl="4"/>
             <a:r>
-              <a:rPr lang="en-US" smtClean="0"/>
+              <a:rPr lang="en-US"/>
               <a:t>Fifth level</a:t>
             </a:r>
             <a:endParaRPr lang="cs-CZ"/>
@@ -484,9 +501,9 @@
 </file>
 
 <file path=ppt/notesSlides/notesSlide1.xml><?xml version="1.0" encoding="utf-8"?>
-<p:notes xmlns:p="http://schemas.openxmlformats.org/presentationml/2006/main" xmlns:a="http://schemas.openxmlformats.org/drawingml/2006/main">
+<p:notes xmlns:a="http://schemas.openxmlformats.org/drawingml/2006/main" xmlns:r="http://schemas.openxmlformats.org/officeDocument/2006/relationships" xmlns:p="http://schemas.openxmlformats.org/presentationml/2006/main">
   <p:cSld>
-    <p:spTree xmlns:r="http://schemas.openxmlformats.org/officeDocument/2006/relationships">
+    <p:spTree>
       <p:nvGrpSpPr>
         <p:cNvPr id="1" name=""/>
         <p:cNvGrpSpPr/>
@@ -526,7 +543,9 @@
               <a:defRPr sz="1200"/>
             </a:lvl1pPr>
           </a:lstStyle>
-          <a:p/>
+          <a:p>
+            <a:endParaRPr/>
+          </a:p>
         </p:txBody>
       </p:sp>
       <p:sp>
@@ -556,8 +575,8 @@
             </a:lvl1pPr>
           </a:lstStyle>
           <a:p>
-            <a:r id="{B7268E1E-0E44-426D-905E-8AD9B19D2182}" type="datetimeFigureOut">
-              <a:rPr lang="cs-CZ" smtClean="0"/>
+            <a:r>
+              <a:rPr lang="cs-CZ"/>
               <a:t>1.7.2013</a:t>
             </a:r>
           </a:p>
@@ -575,8 +594,8 @@
         </p:nvSpPr>
         <p:spPr>
           <a:xfrm>
-            <a:off x="2857500" y="512763"/>
-            <a:ext cx="3429000" cy="2566987"/>
+            <a:off x="2290763" y="512763"/>
+            <a:ext cx="4562475" cy="2566987"/>
           </a:xfrm>
           <a:prstGeom prst="rect">
             <a:avLst/>
@@ -591,7 +610,9 @@
         <p:txBody>
           <a:bodyPr vert="horz" lIns="91440" tIns="45720" rIns="91440" bIns="45720" rtlCol="0" anchor="ctr"/>
           <a:lstStyle/>
-          <a:p/>
+          <a:p>
+            <a:endParaRPr/>
+          </a:p>
         </p:txBody>
       </p:sp>
       <p:sp>
@@ -623,10 +644,7 @@
             </a:r>
           </a:p>
           <a:p>
-            <a:r>
-              <a:rPr lang="en-US"/>
-              <a:t/>
-            </a:r>
+            <a:endParaRPr lang="en-US"/>
           </a:p>
           <a:p>
             <a:r>
@@ -635,16 +653,10 @@
             </a:r>
           </a:p>
           <a:p>
-            <a:r>
-              <a:rPr lang="en-US"/>
-              <a:t/>
-            </a:r>
-          </a:p>
-          <a:p>
-            <a:r>
-              <a:rPr lang="en-US"/>
-              <a:t/>
-            </a:r>
+            <a:endParaRPr lang="en-US"/>
+          </a:p>
+          <a:p>
+            <a:endParaRPr lang="en-US"/>
           </a:p>
           <a:p>
             <a:r>
@@ -653,10 +665,7 @@
             </a:r>
           </a:p>
           <a:p>
-            <a:r>
-              <a:rPr lang="en-US"/>
-              <a:t/>
-            </a:r>
+            <a:endParaRPr lang="en-US"/>
           </a:p>
           <a:p>
             <a:r>
@@ -692,7 +701,9 @@
               <a:defRPr sz="1200"/>
             </a:lvl1pPr>
           </a:lstStyle>
-          <a:p/>
+          <a:p>
+            <a:endParaRPr/>
+          </a:p>
         </p:txBody>
       </p:sp>
       <p:sp>
@@ -722,8 +733,8 @@
             </a:lvl1pPr>
           </a:lstStyle>
           <a:p>
-            <a:r id="{871B2431-D351-4C6E-A3CF-9DFAC0E3E050}" type="slidenum">
-              <a:rPr lang="cs-CZ" smtClean="0"/>
+            <a:r>
+              <a:rPr lang="cs-CZ"/>
               <a:t>‹#›</a:t>
             </a:r>
           </a:p>
@@ -738,9 +749,9 @@
 </file>
 
 <file path=ppt/notesSlides/notesSlide2.xml><?xml version="1.0" encoding="utf-8"?>
-<p:notes xmlns:p="http://schemas.openxmlformats.org/presentationml/2006/main" xmlns:a="http://schemas.openxmlformats.org/drawingml/2006/main">
+<p:notes xmlns:a="http://schemas.openxmlformats.org/drawingml/2006/main" xmlns:r="http://schemas.openxmlformats.org/officeDocument/2006/relationships" xmlns:p="http://schemas.openxmlformats.org/presentationml/2006/main">
   <p:cSld>
-    <p:spTree xmlns:r="http://schemas.openxmlformats.org/officeDocument/2006/relationships">
+    <p:spTree>
       <p:nvGrpSpPr>
         <p:cNvPr id="1" name=""/>
         <p:cNvGrpSpPr/>
@@ -780,7 +791,9 @@
               <a:defRPr sz="1200"/>
             </a:lvl1pPr>
           </a:lstStyle>
-          <a:p/>
+          <a:p>
+            <a:endParaRPr/>
+          </a:p>
         </p:txBody>
       </p:sp>
       <p:sp>
@@ -810,8 +823,8 @@
             </a:lvl1pPr>
           </a:lstStyle>
           <a:p>
-            <a:r id="{B7268E1E-0E44-426D-905E-8AD9B19D2182}" type="datetimeFigureOut">
-              <a:rPr lang="cs-CZ" smtClean="0"/>
+            <a:r>
+              <a:rPr lang="cs-CZ"/>
               <a:t>1.7.2013</a:t>
             </a:r>
           </a:p>
@@ -829,8 +842,8 @@
         </p:nvSpPr>
         <p:spPr>
           <a:xfrm>
-            <a:off x="2857500" y="512763"/>
-            <a:ext cx="3429000" cy="2566987"/>
+            <a:off x="2290763" y="512763"/>
+            <a:ext cx="4562475" cy="2566987"/>
           </a:xfrm>
           <a:prstGeom prst="rect">
             <a:avLst/>
@@ -845,7 +858,9 @@
         <p:txBody>
           <a:bodyPr vert="horz" lIns="91440" tIns="45720" rIns="91440" bIns="45720" rtlCol="0" anchor="ctr"/>
           <a:lstStyle/>
-          <a:p/>
+          <a:p>
+            <a:endParaRPr/>
+          </a:p>
         </p:txBody>
       </p:sp>
       <p:sp>
@@ -877,10 +892,7 @@
             </a:r>
           </a:p>
           <a:p>
-            <a:r>
-              <a:rPr lang="en-US"/>
-              <a:t/>
-            </a:r>
+            <a:endParaRPr lang="en-US"/>
           </a:p>
           <a:p>
             <a:r>
@@ -889,16 +901,10 @@
             </a:r>
           </a:p>
           <a:p>
-            <a:r>
-              <a:rPr lang="en-US"/>
-              <a:t/>
-            </a:r>
-          </a:p>
-          <a:p>
-            <a:r>
-              <a:rPr lang="en-US"/>
-              <a:t/>
-            </a:r>
+            <a:endParaRPr lang="en-US"/>
+          </a:p>
+          <a:p>
+            <a:endParaRPr lang="en-US"/>
           </a:p>
           <a:p>
             <a:r>
@@ -907,10 +913,7 @@
             </a:r>
           </a:p>
           <a:p>
-            <a:r>
-              <a:rPr lang="en-US"/>
-              <a:t/>
-            </a:r>
+            <a:endParaRPr lang="en-US"/>
           </a:p>
           <a:p>
             <a:r>
@@ -946,7 +949,9 @@
               <a:defRPr sz="1200"/>
             </a:lvl1pPr>
           </a:lstStyle>
-          <a:p/>
+          <a:p>
+            <a:endParaRPr/>
+          </a:p>
         </p:txBody>
       </p:sp>
       <p:sp>
@@ -976,8 +981,8 @@
             </a:lvl1pPr>
           </a:lstStyle>
           <a:p>
-            <a:r id="{871B2431-D351-4C6E-A3CF-9DFAC0E3E050}" type="slidenum">
-              <a:rPr lang="cs-CZ" smtClean="0"/>
+            <a:r>
+              <a:rPr lang="cs-CZ"/>
               <a:t>‹#›</a:t>
             </a:r>
           </a:p>
@@ -992,9 +997,9 @@
 </file>
 
 <file path=ppt/notesSlides/notesSlide3.xml><?xml version="1.0" encoding="utf-8"?>
-<p:notes xmlns:p="http://schemas.openxmlformats.org/presentationml/2006/main" xmlns:a="http://schemas.openxmlformats.org/drawingml/2006/main">
+<p:notes xmlns:a="http://schemas.openxmlformats.org/drawingml/2006/main" xmlns:r="http://schemas.openxmlformats.org/officeDocument/2006/relationships" xmlns:p="http://schemas.openxmlformats.org/presentationml/2006/main">
   <p:cSld>
-    <p:spTree xmlns:r="http://schemas.openxmlformats.org/officeDocument/2006/relationships">
+    <p:spTree>
       <p:nvGrpSpPr>
         <p:cNvPr id="1" name=""/>
         <p:cNvGrpSpPr/>
@@ -1034,7 +1039,9 @@
               <a:defRPr sz="1200"/>
             </a:lvl1pPr>
           </a:lstStyle>
-          <a:p/>
+          <a:p>
+            <a:endParaRPr/>
+          </a:p>
         </p:txBody>
       </p:sp>
       <p:sp>
@@ -1064,8 +1071,8 @@
             </a:lvl1pPr>
           </a:lstStyle>
           <a:p>
-            <a:r id="{B7268E1E-0E44-426D-905E-8AD9B19D2182}" type="datetimeFigureOut">
-              <a:rPr lang="cs-CZ" smtClean="0"/>
+            <a:r>
+              <a:rPr lang="cs-CZ"/>
               <a:t>1.7.2013</a:t>
             </a:r>
           </a:p>
@@ -1083,8 +1090,8 @@
         </p:nvSpPr>
         <p:spPr>
           <a:xfrm>
-            <a:off x="2857500" y="512763"/>
-            <a:ext cx="3429000" cy="2566987"/>
+            <a:off x="2290763" y="512763"/>
+            <a:ext cx="4562475" cy="2566987"/>
           </a:xfrm>
           <a:prstGeom prst="rect">
             <a:avLst/>
@@ -1099,7 +1106,9 @@
         <p:txBody>
           <a:bodyPr vert="horz" lIns="91440" tIns="45720" rIns="91440" bIns="45720" rtlCol="0" anchor="ctr"/>
           <a:lstStyle/>
-          <a:p/>
+          <a:p>
+            <a:endParaRPr/>
+          </a:p>
         </p:txBody>
       </p:sp>
       <p:sp>
@@ -1131,10 +1140,7 @@
             </a:r>
           </a:p>
           <a:p>
-            <a:r>
-              <a:rPr lang="en-US"/>
-              <a:t/>
-            </a:r>
+            <a:endParaRPr lang="en-US"/>
           </a:p>
           <a:p>
             <a:r>
@@ -1143,16 +1149,10 @@
             </a:r>
           </a:p>
           <a:p>
-            <a:r>
-              <a:rPr lang="en-US"/>
-              <a:t/>
-            </a:r>
-          </a:p>
-          <a:p>
-            <a:r>
-              <a:rPr lang="en-US"/>
-              <a:t/>
-            </a:r>
+            <a:endParaRPr lang="en-US"/>
+          </a:p>
+          <a:p>
+            <a:endParaRPr lang="en-US"/>
           </a:p>
           <a:p>
             <a:r>
@@ -1161,10 +1161,7 @@
             </a:r>
           </a:p>
           <a:p>
-            <a:r>
-              <a:rPr lang="en-US"/>
-              <a:t/>
-            </a:r>
+            <a:endParaRPr lang="en-US"/>
           </a:p>
           <a:p>
             <a:r>
@@ -1200,7 +1197,9 @@
               <a:defRPr sz="1200"/>
             </a:lvl1pPr>
           </a:lstStyle>
-          <a:p/>
+          <a:p>
+            <a:endParaRPr/>
+          </a:p>
         </p:txBody>
       </p:sp>
       <p:sp>
@@ -1230,8 +1229,8 @@
             </a:lvl1pPr>
           </a:lstStyle>
           <a:p>
-            <a:r id="{871B2431-D351-4C6E-A3CF-9DFAC0E3E050}" type="slidenum">
-              <a:rPr lang="cs-CZ" smtClean="0"/>
+            <a:r>
+              <a:rPr lang="cs-CZ"/>
               <a:t>‹#›</a:t>
             </a:r>
           </a:p>
@@ -1246,9 +1245,9 @@
 </file>
 
 <file path=ppt/notesSlides/notesSlide4.xml><?xml version="1.0" encoding="utf-8"?>
-<p:notes xmlns:p="http://schemas.openxmlformats.org/presentationml/2006/main" xmlns:a="http://schemas.openxmlformats.org/drawingml/2006/main">
+<p:notes xmlns:a="http://schemas.openxmlformats.org/drawingml/2006/main" xmlns:r="http://schemas.openxmlformats.org/officeDocument/2006/relationships" xmlns:p="http://schemas.openxmlformats.org/presentationml/2006/main">
   <p:cSld>
-    <p:spTree xmlns:r="http://schemas.openxmlformats.org/officeDocument/2006/relationships">
+    <p:spTree>
       <p:nvGrpSpPr>
         <p:cNvPr id="1" name=""/>
         <p:cNvGrpSpPr/>
@@ -1288,7 +1287,9 @@
               <a:defRPr sz="1200"/>
             </a:lvl1pPr>
           </a:lstStyle>
-          <a:p/>
+          <a:p>
+            <a:endParaRPr/>
+          </a:p>
         </p:txBody>
       </p:sp>
       <p:sp>
@@ -1318,8 +1319,8 @@
             </a:lvl1pPr>
           </a:lstStyle>
           <a:p>
-            <a:r id="{B7268E1E-0E44-426D-905E-8AD9B19D2182}" type="datetimeFigureOut">
-              <a:rPr lang="cs-CZ" smtClean="0"/>
+            <a:r>
+              <a:rPr lang="cs-CZ"/>
               <a:t>1.7.2013</a:t>
             </a:r>
           </a:p>
@@ -1337,8 +1338,8 @@
         </p:nvSpPr>
         <p:spPr>
           <a:xfrm>
-            <a:off x="2857500" y="512763"/>
-            <a:ext cx="3429000" cy="2566987"/>
+            <a:off x="2290763" y="512763"/>
+            <a:ext cx="4562475" cy="2566987"/>
           </a:xfrm>
           <a:prstGeom prst="rect">
             <a:avLst/>
@@ -1353,7 +1354,9 @@
         <p:txBody>
           <a:bodyPr vert="horz" lIns="91440" tIns="45720" rIns="91440" bIns="45720" rtlCol="0" anchor="ctr"/>
           <a:lstStyle/>
-          <a:p/>
+          <a:p>
+            <a:endParaRPr/>
+          </a:p>
         </p:txBody>
       </p:sp>
       <p:sp>
@@ -1385,10 +1388,7 @@
             </a:r>
           </a:p>
           <a:p>
-            <a:r>
-              <a:rPr lang="en-US"/>
-              <a:t/>
-            </a:r>
+            <a:endParaRPr lang="en-US"/>
           </a:p>
           <a:p>
             <a:r>
@@ -1397,16 +1397,10 @@
             </a:r>
           </a:p>
           <a:p>
-            <a:r>
-              <a:rPr lang="en-US"/>
-              <a:t/>
-            </a:r>
-          </a:p>
-          <a:p>
-            <a:r>
-              <a:rPr lang="en-US"/>
-              <a:t/>
-            </a:r>
+            <a:endParaRPr lang="en-US"/>
+          </a:p>
+          <a:p>
+            <a:endParaRPr lang="en-US"/>
           </a:p>
           <a:p>
             <a:r>
@@ -1415,10 +1409,7 @@
             </a:r>
           </a:p>
           <a:p>
-            <a:r>
-              <a:rPr lang="en-US"/>
-              <a:t/>
-            </a:r>
+            <a:endParaRPr lang="en-US"/>
           </a:p>
           <a:p>
             <a:r>
@@ -1454,7 +1445,9 @@
               <a:defRPr sz="1200"/>
             </a:lvl1pPr>
           </a:lstStyle>
-          <a:p/>
+          <a:p>
+            <a:endParaRPr/>
+          </a:p>
         </p:txBody>
       </p:sp>
       <p:sp>
@@ -1484,8 +1477,8 @@
             </a:lvl1pPr>
           </a:lstStyle>
           <a:p>
-            <a:r id="{871B2431-D351-4C6E-A3CF-9DFAC0E3E050}" type="slidenum">
-              <a:rPr lang="cs-CZ" smtClean="0"/>
+            <a:r>
+              <a:rPr lang="cs-CZ"/>
               <a:t>‹#›</a:t>
             </a:r>
           </a:p>
@@ -1500,9 +1493,9 @@
 </file>
 
 <file path=ppt/notesSlides/notesSlide5.xml><?xml version="1.0" encoding="utf-8"?>
-<p:notes xmlns:p="http://schemas.openxmlformats.org/presentationml/2006/main" xmlns:a="http://schemas.openxmlformats.org/drawingml/2006/main">
+<p:notes xmlns:a="http://schemas.openxmlformats.org/drawingml/2006/main" xmlns:r="http://schemas.openxmlformats.org/officeDocument/2006/relationships" xmlns:p="http://schemas.openxmlformats.org/presentationml/2006/main">
   <p:cSld>
-    <p:spTree xmlns:r="http://schemas.openxmlformats.org/officeDocument/2006/relationships">
+    <p:spTree>
       <p:nvGrpSpPr>
         <p:cNvPr id="1" name=""/>
         <p:cNvGrpSpPr/>
@@ -1542,7 +1535,9 @@
               <a:defRPr sz="1200"/>
             </a:lvl1pPr>
           </a:lstStyle>
-          <a:p/>
+          <a:p>
+            <a:endParaRPr/>
+          </a:p>
         </p:txBody>
       </p:sp>
       <p:sp>
@@ -1572,8 +1567,8 @@
             </a:lvl1pPr>
           </a:lstStyle>
           <a:p>
-            <a:r id="{B7268E1E-0E44-426D-905E-8AD9B19D2182}" type="datetimeFigureOut">
-              <a:rPr lang="cs-CZ" smtClean="0"/>
+            <a:r>
+              <a:rPr lang="cs-CZ"/>
               <a:t>1.7.2013</a:t>
             </a:r>
           </a:p>
@@ -1591,8 +1586,8 @@
         </p:nvSpPr>
         <p:spPr>
           <a:xfrm>
-            <a:off x="2857500" y="512763"/>
-            <a:ext cx="3429000" cy="2566987"/>
+            <a:off x="2290763" y="512763"/>
+            <a:ext cx="4562475" cy="2566987"/>
           </a:xfrm>
           <a:prstGeom prst="rect">
             <a:avLst/>
@@ -1607,7 +1602,9 @@
         <p:txBody>
           <a:bodyPr vert="horz" lIns="91440" tIns="45720" rIns="91440" bIns="45720" rtlCol="0" anchor="ctr"/>
           <a:lstStyle/>
-          <a:p/>
+          <a:p>
+            <a:endParaRPr/>
+          </a:p>
         </p:txBody>
       </p:sp>
       <p:sp>
@@ -1639,10 +1636,7 @@
             </a:r>
           </a:p>
           <a:p>
-            <a:r>
-              <a:rPr lang="en-US"/>
-              <a:t/>
-            </a:r>
+            <a:endParaRPr lang="en-US"/>
           </a:p>
           <a:p>
             <a:r>
@@ -1651,16 +1645,10 @@
             </a:r>
           </a:p>
           <a:p>
-            <a:r>
-              <a:rPr lang="en-US"/>
-              <a:t/>
-            </a:r>
-          </a:p>
-          <a:p>
-            <a:r>
-              <a:rPr lang="en-US"/>
-              <a:t/>
-            </a:r>
+            <a:endParaRPr lang="en-US"/>
+          </a:p>
+          <a:p>
+            <a:endParaRPr lang="en-US"/>
           </a:p>
           <a:p>
             <a:r>
@@ -1669,10 +1657,7 @@
             </a:r>
           </a:p>
           <a:p>
-            <a:r>
-              <a:rPr lang="en-US"/>
-              <a:t/>
-            </a:r>
+            <a:endParaRPr lang="en-US"/>
           </a:p>
           <a:p>
             <a:r>
@@ -1708,7 +1693,9 @@
               <a:defRPr sz="1200"/>
             </a:lvl1pPr>
           </a:lstStyle>
-          <a:p/>
+          <a:p>
+            <a:endParaRPr/>
+          </a:p>
         </p:txBody>
       </p:sp>
       <p:sp>
@@ -1738,8 +1725,8 @@
             </a:lvl1pPr>
           </a:lstStyle>
           <a:p>
-            <a:r id="{871B2431-D351-4C6E-A3CF-9DFAC0E3E050}" type="slidenum">
-              <a:rPr lang="cs-CZ" smtClean="0"/>
+            <a:r>
+              <a:rPr lang="cs-CZ"/>
               <a:t>‹#›</a:t>
             </a:r>
           </a:p>
@@ -1754,9 +1741,9 @@
 </file>
 
 <file path=ppt/notesSlides/notesSlide6.xml><?xml version="1.0" encoding="utf-8"?>
-<p:notes xmlns:p="http://schemas.openxmlformats.org/presentationml/2006/main" xmlns:a="http://schemas.openxmlformats.org/drawingml/2006/main">
+<p:notes xmlns:a="http://schemas.openxmlformats.org/drawingml/2006/main" xmlns:r="http://schemas.openxmlformats.org/officeDocument/2006/relationships" xmlns:p="http://schemas.openxmlformats.org/presentationml/2006/main">
   <p:cSld>
-    <p:spTree xmlns:r="http://schemas.openxmlformats.org/officeDocument/2006/relationships">
+    <p:spTree>
       <p:nvGrpSpPr>
         <p:cNvPr id="1" name=""/>
         <p:cNvGrpSpPr/>
@@ -1796,7 +1783,9 @@
               <a:defRPr sz="1200"/>
             </a:lvl1pPr>
           </a:lstStyle>
-          <a:p/>
+          <a:p>
+            <a:endParaRPr/>
+          </a:p>
         </p:txBody>
       </p:sp>
       <p:sp>
@@ -1826,8 +1815,8 @@
             </a:lvl1pPr>
           </a:lstStyle>
           <a:p>
-            <a:r id="{B7268E1E-0E44-426D-905E-8AD9B19D2182}" type="datetimeFigureOut">
-              <a:rPr lang="cs-CZ" smtClean="0"/>
+            <a:r>
+              <a:rPr lang="cs-CZ"/>
               <a:t>1.7.2013</a:t>
             </a:r>
           </a:p>
@@ -1845,8 +1834,8 @@
         </p:nvSpPr>
         <p:spPr>
           <a:xfrm>
-            <a:off x="2857500" y="512763"/>
-            <a:ext cx="3429000" cy="2566987"/>
+            <a:off x="2290763" y="512763"/>
+            <a:ext cx="4562475" cy="2566987"/>
           </a:xfrm>
           <a:prstGeom prst="rect">
             <a:avLst/>
@@ -1861,7 +1850,9 @@
         <p:txBody>
           <a:bodyPr vert="horz" lIns="91440" tIns="45720" rIns="91440" bIns="45720" rtlCol="0" anchor="ctr"/>
           <a:lstStyle/>
-          <a:p/>
+          <a:p>
+            <a:endParaRPr/>
+          </a:p>
         </p:txBody>
       </p:sp>
       <p:sp>
@@ -1893,10 +1884,7 @@
             </a:r>
           </a:p>
           <a:p>
-            <a:r>
-              <a:rPr lang="en-US"/>
-              <a:t/>
-            </a:r>
+            <a:endParaRPr lang="en-US"/>
           </a:p>
           <a:p>
             <a:r>
@@ -1905,16 +1893,10 @@
             </a:r>
           </a:p>
           <a:p>
-            <a:r>
-              <a:rPr lang="en-US"/>
-              <a:t/>
-            </a:r>
-          </a:p>
-          <a:p>
-            <a:r>
-              <a:rPr lang="en-US"/>
-              <a:t/>
-            </a:r>
+            <a:endParaRPr lang="en-US"/>
+          </a:p>
+          <a:p>
+            <a:endParaRPr lang="en-US"/>
           </a:p>
           <a:p>
             <a:r>
@@ -1923,10 +1905,7 @@
             </a:r>
           </a:p>
           <a:p>
-            <a:r>
-              <a:rPr lang="en-US"/>
-              <a:t/>
-            </a:r>
+            <a:endParaRPr lang="en-US"/>
           </a:p>
           <a:p>
             <a:r>
@@ -1962,7 +1941,9 @@
               <a:defRPr sz="1200"/>
             </a:lvl1pPr>
           </a:lstStyle>
-          <a:p/>
+          <a:p>
+            <a:endParaRPr/>
+          </a:p>
         </p:txBody>
       </p:sp>
       <p:sp>
@@ -1992,8 +1973,8 @@
             </a:lvl1pPr>
           </a:lstStyle>
           <a:p>
-            <a:r id="{871B2431-D351-4C6E-A3CF-9DFAC0E3E050}" type="slidenum">
-              <a:rPr lang="cs-CZ" smtClean="0"/>
+            <a:r>
+              <a:rPr lang="cs-CZ"/>
               <a:t>‹#›</a:t>
             </a:r>
           </a:p>
@@ -2045,10 +2026,9 @@
           <a:lstStyle/>
           <a:p>
             <a:r>
-              <a:rPr lang="en-US" smtClean="0"/>
+              <a:rPr lang="en-US"/>
               <a:t>Click to edit Master title style</a:t>
             </a:r>
-            <a:endParaRPr lang="en-US"/>
           </a:p>
         </p:txBody>
       </p:sp>
@@ -2164,10 +2144,9 @@
           </a:lstStyle>
           <a:p>
             <a:r>
-              <a:rPr lang="en-US" smtClean="0"/>
+              <a:rPr lang="en-US"/>
               <a:t>Click to edit Master subtitle style</a:t>
             </a:r>
-            <a:endParaRPr lang="en-US"/>
           </a:p>
         </p:txBody>
       </p:sp>
@@ -2189,7 +2168,7 @@
             <a:fld id="{1D8BD707-D9CF-40AE-B4C6-C98DA3205C09}" type="datetimeFigureOut">
               <a:rPr lang="en-US" smtClean="0"/>
               <a:pPr/>
-              <a:t>8/1/2011</a:t>
+              <a:t>10/5/2026</a:t>
             </a:fld>
             <a:endParaRPr lang="en-US"/>
           </a:p>
@@ -2279,10 +2258,9 @@
           <a:lstStyle/>
           <a:p>
             <a:r>
-              <a:rPr lang="en-US" smtClean="0"/>
+              <a:rPr lang="en-US"/>
               <a:t>Click to edit Master title style</a:t>
             </a:r>
-            <a:endParaRPr lang="en-US"/>
           </a:p>
         </p:txBody>
       </p:sp>
@@ -2303,38 +2281,37 @@
           <a:p>
             <a:pPr lvl="0"/>
             <a:r>
-              <a:rPr lang="en-US" smtClean="0"/>
+              <a:rPr lang="en-US"/>
               <a:t>Click to edit Master text styles</a:t>
             </a:r>
           </a:p>
           <a:p>
             <a:pPr lvl="1"/>
             <a:r>
-              <a:rPr lang="en-US" smtClean="0"/>
+              <a:rPr lang="en-US"/>
               <a:t>Second level</a:t>
             </a:r>
           </a:p>
           <a:p>
             <a:pPr lvl="2"/>
             <a:r>
-              <a:rPr lang="en-US" smtClean="0"/>
+              <a:rPr lang="en-US"/>
               <a:t>Third level</a:t>
             </a:r>
           </a:p>
           <a:p>
             <a:pPr lvl="3"/>
             <a:r>
-              <a:rPr lang="en-US" smtClean="0"/>
+              <a:rPr lang="en-US"/>
               <a:t>Fourth level</a:t>
             </a:r>
           </a:p>
           <a:p>
             <a:pPr lvl="4"/>
             <a:r>
-              <a:rPr lang="en-US" smtClean="0"/>
+              <a:rPr lang="en-US"/>
               <a:t>Fifth level</a:t>
             </a:r>
-            <a:endParaRPr lang="en-US"/>
           </a:p>
         </p:txBody>
       </p:sp>
@@ -2356,7 +2333,7 @@
             <a:fld id="{1D8BD707-D9CF-40AE-B4C6-C98DA3205C09}" type="datetimeFigureOut">
               <a:rPr lang="en-US" smtClean="0"/>
               <a:pPr/>
-              <a:t>8/1/2011</a:t>
+              <a:t>10/5/2026</a:t>
             </a:fld>
             <a:endParaRPr lang="en-US"/>
           </a:p>
@@ -2451,10 +2428,9 @@
           <a:lstStyle/>
           <a:p>
             <a:r>
-              <a:rPr lang="en-US" smtClean="0"/>
+              <a:rPr lang="en-US"/>
               <a:t>Click to edit Master title style</a:t>
             </a:r>
-            <a:endParaRPr lang="en-US"/>
           </a:p>
         </p:txBody>
       </p:sp>
@@ -2480,38 +2456,37 @@
           <a:p>
             <a:pPr lvl="0"/>
             <a:r>
-              <a:rPr lang="en-US" smtClean="0"/>
+              <a:rPr lang="en-US"/>
               <a:t>Click to edit Master text styles</a:t>
             </a:r>
           </a:p>
           <a:p>
             <a:pPr lvl="1"/>
             <a:r>
-              <a:rPr lang="en-US" smtClean="0"/>
+              <a:rPr lang="en-US"/>
               <a:t>Second level</a:t>
             </a:r>
           </a:p>
           <a:p>
             <a:pPr lvl="2"/>
             <a:r>
-              <a:rPr lang="en-US" smtClean="0"/>
+              <a:rPr lang="en-US"/>
               <a:t>Third level</a:t>
             </a:r>
           </a:p>
           <a:p>
             <a:pPr lvl="3"/>
             <a:r>
-              <a:rPr lang="en-US" smtClean="0"/>
+              <a:rPr lang="en-US"/>
               <a:t>Fourth level</a:t>
             </a:r>
           </a:p>
           <a:p>
             <a:pPr lvl="4"/>
             <a:r>
-              <a:rPr lang="en-US" smtClean="0"/>
+              <a:rPr lang="en-US"/>
               <a:t>Fifth level</a:t>
             </a:r>
-            <a:endParaRPr lang="en-US"/>
           </a:p>
         </p:txBody>
       </p:sp>
@@ -2533,7 +2508,7 @@
             <a:fld id="{1D8BD707-D9CF-40AE-B4C6-C98DA3205C09}" type="datetimeFigureOut">
               <a:rPr lang="en-US" smtClean="0"/>
               <a:pPr/>
-              <a:t>8/1/2011</a:t>
+              <a:t>10/5/2026</a:t>
             </a:fld>
             <a:endParaRPr lang="en-US"/>
           </a:p>
@@ -2623,10 +2598,9 @@
           <a:lstStyle/>
           <a:p>
             <a:r>
-              <a:rPr lang="en-US" smtClean="0"/>
+              <a:rPr lang="en-US"/>
               <a:t>Click to edit Master title style</a:t>
             </a:r>
-            <a:endParaRPr lang="en-US"/>
           </a:p>
         </p:txBody>
       </p:sp>
@@ -2647,38 +2621,37 @@
           <a:p>
             <a:pPr lvl="0"/>
             <a:r>
-              <a:rPr lang="en-US" smtClean="0"/>
+              <a:rPr lang="en-US"/>
               <a:t>Click to edit Master text styles</a:t>
             </a:r>
           </a:p>
           <a:p>
             <a:pPr lvl="1"/>
             <a:r>
-              <a:rPr lang="en-US" smtClean="0"/>
+              <a:rPr lang="en-US"/>
               <a:t>Second level</a:t>
             </a:r>
           </a:p>
           <a:p>
             <a:pPr lvl="2"/>
             <a:r>
-              <a:rPr lang="en-US" smtClean="0"/>
+              <a:rPr lang="en-US"/>
               <a:t>Third level</a:t>
             </a:r>
           </a:p>
           <a:p>
             <a:pPr lvl="3"/>
             <a:r>
-              <a:rPr lang="en-US" smtClean="0"/>
+              <a:rPr lang="en-US"/>
               <a:t>Fourth level</a:t>
             </a:r>
           </a:p>
           <a:p>
             <a:pPr lvl="4"/>
             <a:r>
-              <a:rPr lang="en-US" smtClean="0"/>
+              <a:rPr lang="en-US"/>
               <a:t>Fifth level</a:t>
             </a:r>
-            <a:endParaRPr lang="en-US"/>
           </a:p>
         </p:txBody>
       </p:sp>
@@ -2700,7 +2673,7 @@
             <a:fld id="{1D8BD707-D9CF-40AE-B4C6-C98DA3205C09}" type="datetimeFigureOut">
               <a:rPr lang="en-US" smtClean="0"/>
               <a:pPr/>
-              <a:t>8/1/2011</a:t>
+              <a:t>10/5/2026</a:t>
             </a:fld>
             <a:endParaRPr lang="en-US"/>
           </a:p>
@@ -2799,10 +2772,9 @@
           </a:lstStyle>
           <a:p>
             <a:r>
-              <a:rPr lang="en-US" smtClean="0"/>
+              <a:rPr lang="en-US"/>
               <a:t>Click to edit Master title style</a:t>
             </a:r>
-            <a:endParaRPr lang="en-US"/>
           </a:p>
         </p:txBody>
       </p:sp>
@@ -2919,7 +2891,7 @@
           <a:p>
             <a:pPr lvl="0"/>
             <a:r>
-              <a:rPr lang="en-US" smtClean="0"/>
+              <a:rPr lang="en-US"/>
               <a:t>Click to edit Master text styles</a:t>
             </a:r>
           </a:p>
@@ -2943,7 +2915,7 @@
             <a:fld id="{1D8BD707-D9CF-40AE-B4C6-C98DA3205C09}" type="datetimeFigureOut">
               <a:rPr lang="en-US" smtClean="0"/>
               <a:pPr/>
-              <a:t>8/1/2011</a:t>
+              <a:t>10/5/2026</a:t>
             </a:fld>
             <a:endParaRPr lang="en-US"/>
           </a:p>
@@ -3033,10 +3005,9 @@
           <a:lstStyle/>
           <a:p>
             <a:r>
-              <a:rPr lang="en-US" smtClean="0"/>
+              <a:rPr lang="en-US"/>
               <a:t>Click to edit Master title style</a:t>
             </a:r>
-            <a:endParaRPr lang="en-US"/>
           </a:p>
         </p:txBody>
       </p:sp>
@@ -3090,38 +3061,37 @@
           <a:p>
             <a:pPr lvl="0"/>
             <a:r>
-              <a:rPr lang="en-US" smtClean="0"/>
+              <a:rPr lang="en-US"/>
               <a:t>Click to edit Master text styles</a:t>
             </a:r>
           </a:p>
           <a:p>
             <a:pPr lvl="1"/>
             <a:r>
-              <a:rPr lang="en-US" smtClean="0"/>
+              <a:rPr lang="en-US"/>
               <a:t>Second level</a:t>
             </a:r>
           </a:p>
           <a:p>
             <a:pPr lvl="2"/>
             <a:r>
-              <a:rPr lang="en-US" smtClean="0"/>
+              <a:rPr lang="en-US"/>
               <a:t>Third level</a:t>
             </a:r>
           </a:p>
           <a:p>
             <a:pPr lvl="3"/>
             <a:r>
-              <a:rPr lang="en-US" smtClean="0"/>
+              <a:rPr lang="en-US"/>
               <a:t>Fourth level</a:t>
             </a:r>
           </a:p>
           <a:p>
             <a:pPr lvl="4"/>
             <a:r>
-              <a:rPr lang="en-US" smtClean="0"/>
+              <a:rPr lang="en-US"/>
               <a:t>Fifth level</a:t>
             </a:r>
-            <a:endParaRPr lang="en-US"/>
           </a:p>
         </p:txBody>
       </p:sp>
@@ -3175,38 +3145,37 @@
           <a:p>
             <a:pPr lvl="0"/>
             <a:r>
-              <a:rPr lang="en-US" smtClean="0"/>
+              <a:rPr lang="en-US"/>
               <a:t>Click to edit Master text styles</a:t>
             </a:r>
           </a:p>
           <a:p>
             <a:pPr lvl="1"/>
             <a:r>
-              <a:rPr lang="en-US" smtClean="0"/>
+              <a:rPr lang="en-US"/>
               <a:t>Second level</a:t>
             </a:r>
           </a:p>
           <a:p>
             <a:pPr lvl="2"/>
             <a:r>
-              <a:rPr lang="en-US" smtClean="0"/>
+              <a:rPr lang="en-US"/>
               <a:t>Third level</a:t>
             </a:r>
           </a:p>
           <a:p>
             <a:pPr lvl="3"/>
             <a:r>
-              <a:rPr lang="en-US" smtClean="0"/>
+              <a:rPr lang="en-US"/>
               <a:t>Fourth level</a:t>
             </a:r>
           </a:p>
           <a:p>
             <a:pPr lvl="4"/>
             <a:r>
-              <a:rPr lang="en-US" smtClean="0"/>
+              <a:rPr lang="en-US"/>
               <a:t>Fifth level</a:t>
             </a:r>
-            <a:endParaRPr lang="en-US"/>
           </a:p>
         </p:txBody>
       </p:sp>
@@ -3228,7 +3197,7 @@
             <a:fld id="{1D8BD707-D9CF-40AE-B4C6-C98DA3205C09}" type="datetimeFigureOut">
               <a:rPr lang="en-US" smtClean="0"/>
               <a:pPr/>
-              <a:t>8/1/2011</a:t>
+              <a:t>10/5/2026</a:t>
             </a:fld>
             <a:endParaRPr lang="en-US"/>
           </a:p>
@@ -3322,10 +3291,9 @@
           </a:lstStyle>
           <a:p>
             <a:r>
-              <a:rPr lang="en-US" smtClean="0"/>
+              <a:rPr lang="en-US"/>
               <a:t>Click to edit Master title style</a:t>
             </a:r>
-            <a:endParaRPr lang="en-US"/>
           </a:p>
         </p:txBody>
       </p:sp>
@@ -3388,7 +3356,7 @@
           <a:p>
             <a:pPr lvl="0"/>
             <a:r>
-              <a:rPr lang="en-US" smtClean="0"/>
+              <a:rPr lang="en-US"/>
               <a:t>Click to edit Master text styles</a:t>
             </a:r>
           </a:p>
@@ -3444,38 +3412,37 @@
           <a:p>
             <a:pPr lvl="0"/>
             <a:r>
-              <a:rPr lang="en-US" smtClean="0"/>
+              <a:rPr lang="en-US"/>
               <a:t>Click to edit Master text styles</a:t>
             </a:r>
           </a:p>
           <a:p>
             <a:pPr lvl="1"/>
             <a:r>
-              <a:rPr lang="en-US" smtClean="0"/>
+              <a:rPr lang="en-US"/>
               <a:t>Second level</a:t>
             </a:r>
           </a:p>
           <a:p>
             <a:pPr lvl="2"/>
             <a:r>
-              <a:rPr lang="en-US" smtClean="0"/>
+              <a:rPr lang="en-US"/>
               <a:t>Third level</a:t>
             </a:r>
           </a:p>
           <a:p>
             <a:pPr lvl="3"/>
             <a:r>
-              <a:rPr lang="en-US" smtClean="0"/>
+              <a:rPr lang="en-US"/>
               <a:t>Fourth level</a:t>
             </a:r>
           </a:p>
           <a:p>
             <a:pPr lvl="4"/>
             <a:r>
-              <a:rPr lang="en-US" smtClean="0"/>
+              <a:rPr lang="en-US"/>
               <a:t>Fifth level</a:t>
             </a:r>
-            <a:endParaRPr lang="en-US"/>
           </a:p>
         </p:txBody>
       </p:sp>
@@ -3538,7 +3505,7 @@
           <a:p>
             <a:pPr lvl="0"/>
             <a:r>
-              <a:rPr lang="en-US" smtClean="0"/>
+              <a:rPr lang="en-US"/>
               <a:t>Click to edit Master text styles</a:t>
             </a:r>
           </a:p>
@@ -3594,38 +3561,37 @@
           <a:p>
             <a:pPr lvl="0"/>
             <a:r>
-              <a:rPr lang="en-US" smtClean="0"/>
+              <a:rPr lang="en-US"/>
               <a:t>Click to edit Master text styles</a:t>
             </a:r>
           </a:p>
           <a:p>
             <a:pPr lvl="1"/>
             <a:r>
-              <a:rPr lang="en-US" smtClean="0"/>
+              <a:rPr lang="en-US"/>
               <a:t>Second level</a:t>
             </a:r>
           </a:p>
           <a:p>
             <a:pPr lvl="2"/>
             <a:r>
-              <a:rPr lang="en-US" smtClean="0"/>
+              <a:rPr lang="en-US"/>
               <a:t>Third level</a:t>
             </a:r>
           </a:p>
           <a:p>
             <a:pPr lvl="3"/>
             <a:r>
-              <a:rPr lang="en-US" smtClean="0"/>
+              <a:rPr lang="en-US"/>
               <a:t>Fourth level</a:t>
             </a:r>
           </a:p>
           <a:p>
             <a:pPr lvl="4"/>
             <a:r>
-              <a:rPr lang="en-US" smtClean="0"/>
+              <a:rPr lang="en-US"/>
               <a:t>Fifth level</a:t>
             </a:r>
-            <a:endParaRPr lang="en-US"/>
           </a:p>
         </p:txBody>
       </p:sp>
@@ -3647,7 +3613,7 @@
             <a:fld id="{1D8BD707-D9CF-40AE-B4C6-C98DA3205C09}" type="datetimeFigureOut">
               <a:rPr lang="en-US" smtClean="0"/>
               <a:pPr/>
-              <a:t>8/1/2011</a:t>
+              <a:t>10/5/2026</a:t>
             </a:fld>
             <a:endParaRPr lang="en-US"/>
           </a:p>
@@ -3737,10 +3703,9 @@
           <a:lstStyle/>
           <a:p>
             <a:r>
-              <a:rPr lang="en-US" smtClean="0"/>
+              <a:rPr lang="en-US"/>
               <a:t>Click to edit Master title style</a:t>
             </a:r>
-            <a:endParaRPr lang="en-US"/>
           </a:p>
         </p:txBody>
       </p:sp>
@@ -3762,7 +3727,7 @@
             <a:fld id="{1D8BD707-D9CF-40AE-B4C6-C98DA3205C09}" type="datetimeFigureOut">
               <a:rPr lang="en-US" smtClean="0"/>
               <a:pPr/>
-              <a:t>8/1/2011</a:t>
+              <a:t>10/5/2026</a:t>
             </a:fld>
             <a:endParaRPr lang="en-US"/>
           </a:p>
@@ -3854,7 +3819,7 @@
             <a:fld id="{1D8BD707-D9CF-40AE-B4C6-C98DA3205C09}" type="datetimeFigureOut">
               <a:rPr lang="en-US" smtClean="0"/>
               <a:pPr/>
-              <a:t>8/1/2011</a:t>
+              <a:t>10/5/2026</a:t>
             </a:fld>
             <a:endParaRPr lang="en-US"/>
           </a:p>
@@ -3953,10 +3918,9 @@
           </a:lstStyle>
           <a:p>
             <a:r>
-              <a:rPr lang="en-US" smtClean="0"/>
+              <a:rPr lang="en-US"/>
               <a:t>Click to edit Master title style</a:t>
             </a:r>
-            <a:endParaRPr lang="en-US"/>
           </a:p>
         </p:txBody>
       </p:sp>
@@ -4010,38 +3974,37 @@
           <a:p>
             <a:pPr lvl="0"/>
             <a:r>
-              <a:rPr lang="en-US" smtClean="0"/>
+              <a:rPr lang="en-US"/>
               <a:t>Click to edit Master text styles</a:t>
             </a:r>
           </a:p>
           <a:p>
             <a:pPr lvl="1"/>
             <a:r>
-              <a:rPr lang="en-US" smtClean="0"/>
+              <a:rPr lang="en-US"/>
               <a:t>Second level</a:t>
             </a:r>
           </a:p>
           <a:p>
             <a:pPr lvl="2"/>
             <a:r>
-              <a:rPr lang="en-US" smtClean="0"/>
+              <a:rPr lang="en-US"/>
               <a:t>Third level</a:t>
             </a:r>
           </a:p>
           <a:p>
             <a:pPr lvl="3"/>
             <a:r>
-              <a:rPr lang="en-US" smtClean="0"/>
+              <a:rPr lang="en-US"/>
               <a:t>Fourth level</a:t>
             </a:r>
           </a:p>
           <a:p>
             <a:pPr lvl="4"/>
             <a:r>
-              <a:rPr lang="en-US" smtClean="0"/>
+              <a:rPr lang="en-US"/>
               <a:t>Fifth level</a:t>
             </a:r>
-            <a:endParaRPr lang="en-US"/>
           </a:p>
         </p:txBody>
       </p:sp>
@@ -4104,7 +4067,7 @@
           <a:p>
             <a:pPr lvl="0"/>
             <a:r>
-              <a:rPr lang="en-US" smtClean="0"/>
+              <a:rPr lang="en-US"/>
               <a:t>Click to edit Master text styles</a:t>
             </a:r>
           </a:p>
@@ -4128,7 +4091,7 @@
             <a:fld id="{1D8BD707-D9CF-40AE-B4C6-C98DA3205C09}" type="datetimeFigureOut">
               <a:rPr lang="en-US" smtClean="0"/>
               <a:pPr/>
-              <a:t>8/1/2011</a:t>
+              <a:t>10/5/2026</a:t>
             </a:fld>
             <a:endParaRPr lang="en-US"/>
           </a:p>
@@ -4227,10 +4190,9 @@
           </a:lstStyle>
           <a:p>
             <a:r>
-              <a:rPr lang="en-US" smtClean="0"/>
+              <a:rPr lang="en-US"/>
               <a:t>Click to edit Master title style</a:t>
             </a:r>
-            <a:endParaRPr lang="en-US"/>
           </a:p>
         </p:txBody>
       </p:sp>
@@ -4354,7 +4316,7 @@
           <a:p>
             <a:pPr lvl="0"/>
             <a:r>
-              <a:rPr lang="en-US" smtClean="0"/>
+              <a:rPr lang="en-US"/>
               <a:t>Click to edit Master text styles</a:t>
             </a:r>
           </a:p>
@@ -4378,7 +4340,7 @@
             <a:fld id="{1D8BD707-D9CF-40AE-B4C6-C98DA3205C09}" type="datetimeFigureOut">
               <a:rPr lang="en-US" smtClean="0"/>
               <a:pPr/>
-              <a:t>8/1/2011</a:t>
+              <a:t>10/5/2026</a:t>
             </a:fld>
             <a:endParaRPr lang="en-US"/>
           </a:p>
@@ -4483,10 +4445,9 @@
           <a:lstStyle/>
           <a:p>
             <a:r>
-              <a:rPr lang="en-US" smtClean="0"/>
+              <a:rPr lang="en-US"/>
               <a:t>Click to edit Master title style</a:t>
             </a:r>
-            <a:endParaRPr lang="en-US"/>
           </a:p>
         </p:txBody>
       </p:sp>
@@ -4517,38 +4478,37 @@
           <a:p>
             <a:pPr lvl="0"/>
             <a:r>
-              <a:rPr lang="en-US" smtClean="0"/>
+              <a:rPr lang="en-US"/>
               <a:t>Click to edit Master text styles</a:t>
             </a:r>
           </a:p>
           <a:p>
             <a:pPr lvl="1"/>
             <a:r>
-              <a:rPr lang="en-US" smtClean="0"/>
+              <a:rPr lang="en-US"/>
               <a:t>Second level</a:t>
             </a:r>
           </a:p>
           <a:p>
             <a:pPr lvl="2"/>
             <a:r>
-              <a:rPr lang="en-US" smtClean="0"/>
+              <a:rPr lang="en-US"/>
               <a:t>Third level</a:t>
             </a:r>
           </a:p>
           <a:p>
             <a:pPr lvl="3"/>
             <a:r>
-              <a:rPr lang="en-US" smtClean="0"/>
+              <a:rPr lang="en-US"/>
               <a:t>Fourth level</a:t>
             </a:r>
           </a:p>
           <a:p>
             <a:pPr lvl="4"/>
             <a:r>
-              <a:rPr lang="en-US" smtClean="0"/>
+              <a:rPr lang="en-US"/>
               <a:t>Fifth level</a:t>
             </a:r>
-            <a:endParaRPr lang="en-US"/>
           </a:p>
         </p:txBody>
       </p:sp>
@@ -4588,7 +4548,7 @@
             <a:fld id="{1D8BD707-D9CF-40AE-B4C6-C98DA3205C09}" type="datetimeFigureOut">
               <a:rPr lang="en-US" smtClean="0"/>
               <a:pPr/>
-              <a:t>8/1/2011</a:t>
+              <a:t>10/5/2026</a:t>
             </a:fld>
             <a:endParaRPr lang="en-US"/>
           </a:p>
@@ -4943,7 +4903,7 @@
 </file>
 
 <file path=ppt/slides/slide1.xml><?xml version="1.0" encoding="utf-8"?>
-<p:sld xmlns:p="http://schemas.openxmlformats.org/presentationml/2006/main" xmlns:a="http://schemas.openxmlformats.org/drawingml/2006/main" xmlns:r="http://schemas.openxmlformats.org/officeDocument/2006/relationships">
+<p:sld xmlns:a="http://schemas.openxmlformats.org/drawingml/2006/main" xmlns:r="http://schemas.openxmlformats.org/officeDocument/2006/relationships" xmlns:p="http://schemas.openxmlformats.org/presentationml/2006/main">
   <p:cSld>
     <p:spTree>
       <p:nvGrpSpPr>
@@ -4961,12 +4921,12 @@
       </p:grpSpPr>
       <p:sp>
         <p:nvSpPr>
-          <p:cNvPr name="Freeform 2" id="2"/>
+          <p:cNvPr id="2" name="Freeform 2"/>
           <p:cNvSpPr/>
           <p:nvPr/>
         </p:nvSpPr>
         <p:spPr>
-          <a:xfrm flipH="false" flipV="false" rot="0">
+          <a:xfrm>
             <a:off x="0" y="0"/>
             <a:ext cx="18288000" cy="10287000"/>
           </a:xfrm>
@@ -4975,9 +4935,9 @@
             <a:gdLst/>
             <a:ahLst/>
             <a:cxnLst/>
-            <a:rect r="r" b="b" t="t" l="l"/>
+            <a:rect l="l" t="t" r="r" b="b"/>
             <a:pathLst>
-              <a:path h="10287000" w="18288000">
+              <a:path w="18288000" h="10287000">
                 <a:moveTo>
                   <a:pt x="0" y="0"/>
                 </a:moveTo>
@@ -5000,155 +4960,33 @@
           <a:blipFill>
             <a:blip r:embed="rId3"/>
             <a:stretch>
-              <a:fillRect l="0" t="0" r="0" b="0"/>
+              <a:fillRect/>
             </a:stretch>
           </a:blipFill>
         </p:spPr>
       </p:sp>
       <p:grpSp>
         <p:nvGrpSpPr>
-          <p:cNvPr name="Group 3" id="3"/>
+          <p:cNvPr id="7" name="Group 7"/>
           <p:cNvGrpSpPr/>
           <p:nvPr/>
         </p:nvGrpSpPr>
         <p:grpSpPr>
-          <a:xfrm rot="0">
-            <a:off x="5409209" y="509368"/>
-            <a:ext cx="3382137" cy="1375982"/>
+          <a:xfrm>
+            <a:off x="9057056" y="702888"/>
+            <a:ext cx="4510126" cy="988933"/>
             <a:chOff x="0" y="0"/>
-            <a:chExt cx="4509516" cy="1834642"/>
+            <a:chExt cx="6013501" cy="1318578"/>
           </a:xfrm>
         </p:grpSpPr>
         <p:sp>
           <p:nvSpPr>
-            <p:cNvPr name="Freeform 4" id="4"/>
+            <p:cNvPr id="8" name="Freeform 8"/>
             <p:cNvSpPr/>
             <p:nvPr/>
           </p:nvSpPr>
           <p:spPr>
-            <a:xfrm flipH="false" flipV="false" rot="0">
-              <a:off x="0" y="0"/>
-              <a:ext cx="4509516" cy="1834642"/>
-            </a:xfrm>
-            <a:custGeom>
-              <a:avLst/>
-              <a:gdLst/>
-              <a:ahLst/>
-              <a:cxnLst/>
-              <a:rect r="r" b="b" t="t" l="l"/>
-              <a:pathLst>
-                <a:path h="1834642" w="4509516">
-                  <a:moveTo>
-                    <a:pt x="0" y="0"/>
-                  </a:moveTo>
-                  <a:lnTo>
-                    <a:pt x="4509516" y="0"/>
-                  </a:lnTo>
-                  <a:lnTo>
-                    <a:pt x="4509516" y="1834642"/>
-                  </a:lnTo>
-                  <a:lnTo>
-                    <a:pt x="0" y="1834642"/>
-                  </a:lnTo>
-                  <a:lnTo>
-                    <a:pt x="0" y="0"/>
-                  </a:lnTo>
-                  <a:close/>
-                </a:path>
-              </a:pathLst>
-            </a:custGeom>
-            <a:blipFill>
-              <a:blip r:embed="rId4"/>
-              <a:stretch>
-                <a:fillRect l="0" t="-72899" r="0" b="-72899"/>
-              </a:stretch>
-            </a:blipFill>
-          </p:spPr>
-        </p:sp>
-      </p:grpSp>
-      <p:grpSp>
-        <p:nvGrpSpPr>
-          <p:cNvPr name="Group 5" id="5"/>
-          <p:cNvGrpSpPr/>
-          <p:nvPr/>
-        </p:nvGrpSpPr>
-        <p:grpSpPr>
-          <a:xfrm rot="0">
-            <a:off x="649738" y="537277"/>
-            <a:ext cx="4337314" cy="1320165"/>
-            <a:chOff x="0" y="0"/>
-            <a:chExt cx="5783085" cy="1760220"/>
-          </a:xfrm>
-        </p:grpSpPr>
-        <p:sp>
-          <p:nvSpPr>
-            <p:cNvPr name="Freeform 6" id="6"/>
-            <p:cNvSpPr/>
-            <p:nvPr/>
-          </p:nvSpPr>
-          <p:spPr>
-            <a:xfrm flipH="false" flipV="false" rot="0">
-              <a:off x="0" y="0"/>
-              <a:ext cx="5783072" cy="1760220"/>
-            </a:xfrm>
-            <a:custGeom>
-              <a:avLst/>
-              <a:gdLst/>
-              <a:ahLst/>
-              <a:cxnLst/>
-              <a:rect r="r" b="b" t="t" l="l"/>
-              <a:pathLst>
-                <a:path h="1760220" w="5783072">
-                  <a:moveTo>
-                    <a:pt x="0" y="0"/>
-                  </a:moveTo>
-                  <a:lnTo>
-                    <a:pt x="5783072" y="0"/>
-                  </a:lnTo>
-                  <a:lnTo>
-                    <a:pt x="5783072" y="1760220"/>
-                  </a:lnTo>
-                  <a:lnTo>
-                    <a:pt x="0" y="1760220"/>
-                  </a:lnTo>
-                  <a:lnTo>
-                    <a:pt x="0" y="0"/>
-                  </a:lnTo>
-                  <a:close/>
-                </a:path>
-              </a:pathLst>
-            </a:custGeom>
-            <a:blipFill>
-              <a:blip r:embed="rId5"/>
-              <a:stretch>
-                <a:fillRect l="-729" t="0" r="-729" b="0"/>
-              </a:stretch>
-            </a:blipFill>
-          </p:spPr>
-        </p:sp>
-      </p:grpSp>
-      <p:grpSp>
-        <p:nvGrpSpPr>
-          <p:cNvPr name="Group 7" id="7"/>
-          <p:cNvGrpSpPr/>
-          <p:nvPr/>
-        </p:nvGrpSpPr>
-        <p:grpSpPr>
-          <a:xfrm rot="0">
-            <a:off x="9057056" y="702888"/>
-            <a:ext cx="4510126" cy="988933"/>
-            <a:chOff x="0" y="0"/>
-            <a:chExt cx="6013501" cy="1318578"/>
-          </a:xfrm>
-        </p:grpSpPr>
-        <p:sp>
-          <p:nvSpPr>
-            <p:cNvPr name="Freeform 8" id="8"/>
-            <p:cNvSpPr/>
-            <p:nvPr/>
-          </p:nvSpPr>
-          <p:spPr>
-            <a:xfrm flipH="false" flipV="false" rot="0">
+            <a:xfrm>
               <a:off x="0" y="0"/>
               <a:ext cx="6013450" cy="1318514"/>
             </a:xfrm>
@@ -5157,9 +4995,9 @@
               <a:gdLst/>
               <a:ahLst/>
               <a:cxnLst/>
-              <a:rect r="r" b="b" t="t" l="l"/>
+              <a:rect l="l" t="t" r="r" b="b"/>
               <a:pathLst>
-                <a:path h="1318514" w="6013450">
+                <a:path w="6013450" h="1318514">
                   <a:moveTo>
                     <a:pt x="0" y="0"/>
                   </a:moveTo>
@@ -5180,9 +5018,9 @@
               </a:pathLst>
             </a:custGeom>
             <a:blipFill>
-              <a:blip r:embed="rId6"/>
+              <a:blip r:embed="rId4"/>
               <a:stretch>
-                <a:fillRect l="0" t="0" r="0" b="-4"/>
+                <a:fillRect b="-4"/>
               </a:stretch>
             </a:blipFill>
           </p:spPr>
@@ -5190,12 +5028,12 @@
       </p:grpSp>
       <p:grpSp>
         <p:nvGrpSpPr>
-          <p:cNvPr name="Group 9" id="9"/>
+          <p:cNvPr id="9" name="Group 9"/>
           <p:cNvGrpSpPr/>
           <p:nvPr/>
         </p:nvGrpSpPr>
         <p:grpSpPr>
-          <a:xfrm rot="0">
+          <a:xfrm>
             <a:off x="13820003" y="526933"/>
             <a:ext cx="4220718" cy="1547222"/>
             <a:chOff x="0" y="0"/>
@@ -5204,12 +5042,12 @@
         </p:grpSpPr>
         <p:sp>
           <p:nvSpPr>
-            <p:cNvPr name="Freeform 10" id="10"/>
+            <p:cNvPr id="10" name="Freeform 10"/>
             <p:cNvSpPr/>
             <p:nvPr/>
           </p:nvSpPr>
           <p:spPr>
-            <a:xfrm flipH="false" flipV="false" rot="0">
+            <a:xfrm>
               <a:off x="0" y="0"/>
               <a:ext cx="5627624" cy="2062988"/>
             </a:xfrm>
@@ -5218,9 +5056,9 @@
               <a:gdLst/>
               <a:ahLst/>
               <a:cxnLst/>
-              <a:rect r="r" b="b" t="t" l="l"/>
+              <a:rect l="l" t="t" r="r" b="b"/>
               <a:pathLst>
-                <a:path h="2062988" w="5627624">
+                <a:path w="5627624" h="2062988">
                   <a:moveTo>
                     <a:pt x="0" y="0"/>
                   </a:moveTo>
@@ -5241,9 +5079,9 @@
               </a:pathLst>
             </a:custGeom>
             <a:blipFill>
-              <a:blip r:embed="rId7"/>
+              <a:blip r:embed="rId5"/>
               <a:stretch>
-                <a:fillRect l="0" t="0" r="0" b="1"/>
+                <a:fillRect b="1"/>
               </a:stretch>
             </a:blipFill>
           </p:spPr>
@@ -5251,12 +5089,12 @@
       </p:grpSp>
       <p:sp>
         <p:nvSpPr>
-          <p:cNvPr name="Freeform 11" id="11"/>
+          <p:cNvPr id="11" name="Freeform 11"/>
           <p:cNvSpPr/>
           <p:nvPr/>
         </p:nvSpPr>
         <p:spPr>
-          <a:xfrm flipH="false" flipV="false" rot="-1134415">
+          <a:xfrm rot="-1134415">
             <a:off x="324660" y="2398814"/>
             <a:ext cx="2404192" cy="2404192"/>
           </a:xfrm>
@@ -5265,9 +5103,9 @@
             <a:gdLst/>
             <a:ahLst/>
             <a:cxnLst/>
-            <a:rect r="r" b="b" t="t" l="l"/>
+            <a:rect l="l" t="t" r="r" b="b"/>
             <a:pathLst>
-              <a:path h="2404192" w="2404192">
+              <a:path w="2404192" h="2404192">
                 <a:moveTo>
                   <a:pt x="0" y="0"/>
                 </a:moveTo>
@@ -5288,21 +5126,21 @@
             </a:pathLst>
           </a:custGeom>
           <a:blipFill>
-            <a:blip r:embed="rId8"/>
+            <a:blip r:embed="rId6"/>
             <a:stretch>
-              <a:fillRect l="0" t="0" r="0" b="0"/>
+              <a:fillRect/>
             </a:stretch>
           </a:blipFill>
         </p:spPr>
       </p:sp>
       <p:sp>
         <p:nvSpPr>
-          <p:cNvPr name="Freeform 12" id="12"/>
+          <p:cNvPr id="12" name="Freeform 12"/>
           <p:cNvSpPr/>
           <p:nvPr/>
         </p:nvSpPr>
         <p:spPr>
-          <a:xfrm flipH="false" flipV="false" rot="0">
+          <a:xfrm>
             <a:off x="16262600" y="2577575"/>
             <a:ext cx="1495512" cy="1328984"/>
           </a:xfrm>
@@ -5311,9 +5149,9 @@
             <a:gdLst/>
             <a:ahLst/>
             <a:cxnLst/>
-            <a:rect r="r" b="b" t="t" l="l"/>
+            <a:rect l="l" t="t" r="r" b="b"/>
             <a:pathLst>
-              <a:path h="1328984" w="1495512">
+              <a:path w="1495512" h="1328984">
                 <a:moveTo>
                   <a:pt x="0" y="0"/>
                 </a:moveTo>
@@ -5334,15 +5172,15 @@
             </a:pathLst>
           </a:custGeom>
           <a:blipFill>
-            <a:blip r:embed="rId9">
+            <a:blip r:embed="rId7">
               <a:extLst>
                 <a:ext uri="{96DAC541-7B7A-43D3-8B79-37D633B846F1}">
-                  <asvg:svgBlip xmlns:asvg="http://schemas.microsoft.com/office/drawing/2016/SVG/main" r:embed="rId10"/>
+                  <asvg:svgBlip xmlns:asvg="http://schemas.microsoft.com/office/drawing/2016/SVG/main" r:embed="rId8"/>
                 </a:ext>
               </a:extLst>
             </a:blip>
             <a:stretch>
-              <a:fillRect l="-13975" t="-29197" r="0" b="0"/>
+              <a:fillRect l="-13975" t="-29197"/>
             </a:stretch>
           </a:blipFill>
           <a:ln cap="sq">
@@ -5354,12 +5192,12 @@
       </p:sp>
       <p:sp>
         <p:nvSpPr>
-          <p:cNvPr name="Freeform 13" id="13"/>
+          <p:cNvPr id="13" name="Freeform 13"/>
           <p:cNvSpPr/>
           <p:nvPr/>
         </p:nvSpPr>
         <p:spPr>
-          <a:xfrm flipH="false" flipV="false" rot="0">
+          <a:xfrm>
             <a:off x="0" y="9424245"/>
             <a:ext cx="18288000" cy="862755"/>
           </a:xfrm>
@@ -5368,9 +5206,9 @@
             <a:gdLst/>
             <a:ahLst/>
             <a:cxnLst/>
-            <a:rect r="r" b="b" t="t" l="l"/>
+            <a:rect l="l" t="t" r="r" b="b"/>
             <a:pathLst>
-              <a:path h="862755" w="18288000">
+              <a:path w="18288000" h="862755">
                 <a:moveTo>
                   <a:pt x="0" y="0"/>
                 </a:moveTo>
@@ -5391,27 +5229,27 @@
             </a:pathLst>
           </a:custGeom>
           <a:blipFill>
-            <a:blip r:embed="rId11">
+            <a:blip r:embed="rId9">
               <a:extLst>
                 <a:ext uri="{96DAC541-7B7A-43D3-8B79-37D633B846F1}">
-                  <asvg:svgBlip xmlns:asvg="http://schemas.microsoft.com/office/drawing/2016/SVG/main" r:embed="rId12"/>
+                  <asvg:svgBlip xmlns:asvg="http://schemas.microsoft.com/office/drawing/2016/SVG/main" r:embed="rId10"/>
                 </a:ext>
               </a:extLst>
             </a:blip>
             <a:stretch>
-              <a:fillRect l="0" t="0" r="0" b="0"/>
+              <a:fillRect/>
             </a:stretch>
           </a:blipFill>
         </p:spPr>
       </p:sp>
       <p:grpSp>
         <p:nvGrpSpPr>
-          <p:cNvPr name="Group 14" id="14"/>
+          <p:cNvPr id="14" name="Group 14"/>
           <p:cNvGrpSpPr/>
           <p:nvPr/>
         </p:nvGrpSpPr>
         <p:grpSpPr>
-          <a:xfrm rot="0">
+          <a:xfrm>
             <a:off x="1466773" y="4994201"/>
             <a:ext cx="664213" cy="664213"/>
             <a:chOff x="0" y="0"/>
@@ -5420,12 +5258,12 @@
         </p:grpSpPr>
         <p:grpSp>
           <p:nvGrpSpPr>
-            <p:cNvPr name="Group 15" id="15"/>
+            <p:cNvPr id="15" name="Group 15"/>
             <p:cNvGrpSpPr/>
             <p:nvPr/>
           </p:nvGrpSpPr>
           <p:grpSpPr>
-            <a:xfrm rot="0">
+            <a:xfrm>
               <a:off x="0" y="0"/>
               <a:ext cx="885617" cy="885617"/>
               <a:chOff x="0" y="0"/>
@@ -5434,12 +5272,12 @@
           </p:grpSpPr>
           <p:sp>
             <p:nvSpPr>
-              <p:cNvPr name="Freeform 16" id="16"/>
+              <p:cNvPr id="16" name="Freeform 16"/>
               <p:cNvSpPr/>
               <p:nvPr/>
             </p:nvSpPr>
             <p:spPr>
-              <a:xfrm flipH="false" flipV="false" rot="0">
+              <a:xfrm>
                 <a:off x="0" y="0"/>
                 <a:ext cx="812800" cy="812800"/>
               </a:xfrm>
@@ -5448,9 +5286,9 @@
                 <a:gdLst/>
                 <a:ahLst/>
                 <a:cxnLst/>
-                <a:rect r="r" b="b" t="t" l="l"/>
+                <a:rect l="l" t="t" r="r" b="b"/>
                 <a:pathLst>
-                  <a:path h="812800" w="812800">
+                  <a:path w="812800" h="812800">
                     <a:moveTo>
                       <a:pt x="406400" y="0"/>
                     </a:moveTo>
@@ -5485,8 +5323,8 @@
           </p:sp>
           <p:sp>
             <p:nvSpPr>
-              <p:cNvPr name="TextBox 17" id="17"/>
-              <p:cNvSpPr txBox="true"/>
+              <p:cNvPr id="17" name="TextBox 17"/>
+              <p:cNvSpPr txBox="1"/>
               <p:nvPr/>
             </p:nvSpPr>
             <p:spPr>
@@ -5499,7 +5337,7 @@
               </a:prstGeom>
             </p:spPr>
             <p:txBody>
-              <a:bodyPr anchor="ctr" rtlCol="false" tIns="50800" lIns="50800" bIns="50800" rIns="50800"/>
+              <a:bodyPr lIns="50800" tIns="50800" rIns="50800" bIns="50800" rtlCol="0" anchor="ctr"/>
               <a:lstStyle/>
               <a:p>
                 <a:pPr algn="ctr">
@@ -5507,18 +5345,19 @@
                     <a:spcPts val="3024"/>
                   </a:lnSpc>
                 </a:pPr>
+                <a:endParaRPr/>
               </a:p>
             </p:txBody>
           </p:sp>
         </p:grpSp>
         <p:sp>
           <p:nvSpPr>
-            <p:cNvPr name="Freeform 18" id="18"/>
+            <p:cNvPr id="18" name="Freeform 18"/>
             <p:cNvSpPr/>
             <p:nvPr/>
           </p:nvSpPr>
           <p:spPr>
-            <a:xfrm flipH="false" flipV="false" rot="0">
+            <a:xfrm>
               <a:off x="239458" y="180882"/>
               <a:ext cx="406701" cy="523854"/>
             </a:xfrm>
@@ -5527,9 +5366,9 @@
               <a:gdLst/>
               <a:ahLst/>
               <a:cxnLst/>
-              <a:rect r="r" b="b" t="t" l="l"/>
+              <a:rect l="l" t="t" r="r" b="b"/>
               <a:pathLst>
-                <a:path h="523854" w="406701">
+                <a:path w="406701" h="523854">
                   <a:moveTo>
                     <a:pt x="0" y="0"/>
                   </a:moveTo>
@@ -5550,15 +5389,15 @@
               </a:pathLst>
             </a:custGeom>
             <a:blipFill>
-              <a:blip r:embed="rId13">
+              <a:blip r:embed="rId11">
                 <a:extLst>
                   <a:ext uri="{96DAC541-7B7A-43D3-8B79-37D633B846F1}">
-                    <asvg:svgBlip xmlns:asvg="http://schemas.microsoft.com/office/drawing/2016/SVG/main" r:embed="rId14"/>
+                    <asvg:svgBlip xmlns:asvg="http://schemas.microsoft.com/office/drawing/2016/SVG/main" r:embed="rId12"/>
                   </a:ext>
                 </a:extLst>
               </a:blip>
               <a:stretch>
-                <a:fillRect l="0" t="0" r="0" b="0"/>
+                <a:fillRect/>
               </a:stretch>
             </a:blipFill>
           </p:spPr>
@@ -5566,12 +5405,12 @@
       </p:grpSp>
       <p:grpSp>
         <p:nvGrpSpPr>
-          <p:cNvPr name="Group 19" id="19"/>
+          <p:cNvPr id="19" name="Group 19"/>
           <p:cNvGrpSpPr/>
           <p:nvPr/>
         </p:nvGrpSpPr>
         <p:grpSpPr>
-          <a:xfrm rot="0">
+          <a:xfrm>
             <a:off x="1466773" y="6067989"/>
             <a:ext cx="664213" cy="664213"/>
             <a:chOff x="0" y="0"/>
@@ -5580,12 +5419,12 @@
         </p:grpSpPr>
         <p:grpSp>
           <p:nvGrpSpPr>
-            <p:cNvPr name="Group 20" id="20"/>
+            <p:cNvPr id="20" name="Group 20"/>
             <p:cNvGrpSpPr/>
             <p:nvPr/>
           </p:nvGrpSpPr>
           <p:grpSpPr>
-            <a:xfrm rot="0">
+            <a:xfrm>
               <a:off x="0" y="0"/>
               <a:ext cx="885617" cy="885617"/>
               <a:chOff x="0" y="0"/>
@@ -5594,12 +5433,12 @@
           </p:grpSpPr>
           <p:sp>
             <p:nvSpPr>
-              <p:cNvPr name="Freeform 21" id="21"/>
+              <p:cNvPr id="21" name="Freeform 21"/>
               <p:cNvSpPr/>
               <p:nvPr/>
             </p:nvSpPr>
             <p:spPr>
-              <a:xfrm flipH="false" flipV="false" rot="0">
+              <a:xfrm>
                 <a:off x="0" y="0"/>
                 <a:ext cx="812800" cy="812800"/>
               </a:xfrm>
@@ -5608,9 +5447,9 @@
                 <a:gdLst/>
                 <a:ahLst/>
                 <a:cxnLst/>
-                <a:rect r="r" b="b" t="t" l="l"/>
+                <a:rect l="l" t="t" r="r" b="b"/>
                 <a:pathLst>
-                  <a:path h="812800" w="812800">
+                  <a:path w="812800" h="812800">
                     <a:moveTo>
                       <a:pt x="406400" y="0"/>
                     </a:moveTo>
@@ -5645,8 +5484,8 @@
           </p:sp>
           <p:sp>
             <p:nvSpPr>
-              <p:cNvPr name="TextBox 22" id="22"/>
-              <p:cNvSpPr txBox="true"/>
+              <p:cNvPr id="22" name="TextBox 22"/>
+              <p:cNvSpPr txBox="1"/>
               <p:nvPr/>
             </p:nvSpPr>
             <p:spPr>
@@ -5659,7 +5498,7 @@
               </a:prstGeom>
             </p:spPr>
             <p:txBody>
-              <a:bodyPr anchor="ctr" rtlCol="false" tIns="50800" lIns="50800" bIns="50800" rIns="50800"/>
+              <a:bodyPr lIns="50800" tIns="50800" rIns="50800" bIns="50800" rtlCol="0" anchor="ctr"/>
               <a:lstStyle/>
               <a:p>
                 <a:pPr algn="ctr">
@@ -5667,18 +5506,19 @@
                     <a:spcPts val="3024"/>
                   </a:lnSpc>
                 </a:pPr>
+                <a:endParaRPr/>
               </a:p>
             </p:txBody>
           </p:sp>
         </p:grpSp>
         <p:sp>
           <p:nvSpPr>
-            <p:cNvPr name="Freeform 23" id="23"/>
+            <p:cNvPr id="23" name="Freeform 23"/>
             <p:cNvSpPr/>
             <p:nvPr/>
           </p:nvSpPr>
           <p:spPr>
-            <a:xfrm flipH="false" flipV="false" rot="0">
+            <a:xfrm>
               <a:off x="158334" y="239021"/>
               <a:ext cx="568949" cy="407574"/>
             </a:xfrm>
@@ -5687,9 +5527,9 @@
               <a:gdLst/>
               <a:ahLst/>
               <a:cxnLst/>
-              <a:rect r="r" b="b" t="t" l="l"/>
+              <a:rect l="l" t="t" r="r" b="b"/>
               <a:pathLst>
-                <a:path h="407574" w="568949">
+                <a:path w="568949" h="407574">
                   <a:moveTo>
                     <a:pt x="0" y="0"/>
                   </a:moveTo>
@@ -5710,15 +5550,15 @@
               </a:pathLst>
             </a:custGeom>
             <a:blipFill>
-              <a:blip r:embed="rId15">
+              <a:blip r:embed="rId13">
                 <a:extLst>
                   <a:ext uri="{96DAC541-7B7A-43D3-8B79-37D633B846F1}">
-                    <asvg:svgBlip xmlns:asvg="http://schemas.microsoft.com/office/drawing/2016/SVG/main" r:embed="rId16"/>
+                    <asvg:svgBlip xmlns:asvg="http://schemas.microsoft.com/office/drawing/2016/SVG/main" r:embed="rId14"/>
                   </a:ext>
                 </a:extLst>
               </a:blip>
               <a:stretch>
-                <a:fillRect l="0" t="0" r="0" b="0"/>
+                <a:fillRect/>
               </a:stretch>
             </a:blipFill>
           </p:spPr>
@@ -5726,12 +5566,12 @@
       </p:grpSp>
       <p:grpSp>
         <p:nvGrpSpPr>
-          <p:cNvPr name="Group 24" id="24"/>
+          <p:cNvPr id="24" name="Group 24"/>
           <p:cNvGrpSpPr/>
           <p:nvPr/>
         </p:nvGrpSpPr>
         <p:grpSpPr>
-          <a:xfrm rot="0">
+          <a:xfrm>
             <a:off x="1466773" y="7137695"/>
             <a:ext cx="664213" cy="664213"/>
             <a:chOff x="0" y="0"/>
@@ -5740,12 +5580,12 @@
         </p:grpSpPr>
         <p:grpSp>
           <p:nvGrpSpPr>
-            <p:cNvPr name="Group 25" id="25"/>
+            <p:cNvPr id="25" name="Group 25"/>
             <p:cNvGrpSpPr/>
             <p:nvPr/>
           </p:nvGrpSpPr>
           <p:grpSpPr>
-            <a:xfrm rot="0">
+            <a:xfrm>
               <a:off x="0" y="0"/>
               <a:ext cx="885617" cy="885617"/>
               <a:chOff x="0" y="0"/>
@@ -5754,12 +5594,12 @@
           </p:grpSpPr>
           <p:sp>
             <p:nvSpPr>
-              <p:cNvPr name="Freeform 26" id="26"/>
+              <p:cNvPr id="26" name="Freeform 26"/>
               <p:cNvSpPr/>
               <p:nvPr/>
             </p:nvSpPr>
             <p:spPr>
-              <a:xfrm flipH="false" flipV="false" rot="0">
+              <a:xfrm>
                 <a:off x="0" y="0"/>
                 <a:ext cx="812800" cy="812800"/>
               </a:xfrm>
@@ -5768,9 +5608,9 @@
                 <a:gdLst/>
                 <a:ahLst/>
                 <a:cxnLst/>
-                <a:rect r="r" b="b" t="t" l="l"/>
+                <a:rect l="l" t="t" r="r" b="b"/>
                 <a:pathLst>
-                  <a:path h="812800" w="812800">
+                  <a:path w="812800" h="812800">
                     <a:moveTo>
                       <a:pt x="406400" y="0"/>
                     </a:moveTo>
@@ -5805,8 +5645,8 @@
           </p:sp>
           <p:sp>
             <p:nvSpPr>
-              <p:cNvPr name="TextBox 27" id="27"/>
-              <p:cNvSpPr txBox="true"/>
+              <p:cNvPr id="27" name="TextBox 27"/>
+              <p:cNvSpPr txBox="1"/>
               <p:nvPr/>
             </p:nvSpPr>
             <p:spPr>
@@ -5819,7 +5659,7 @@
               </a:prstGeom>
             </p:spPr>
             <p:txBody>
-              <a:bodyPr anchor="ctr" rtlCol="false" tIns="50800" lIns="50800" bIns="50800" rIns="50800"/>
+              <a:bodyPr lIns="50800" tIns="50800" rIns="50800" bIns="50800" rtlCol="0" anchor="ctr"/>
               <a:lstStyle/>
               <a:p>
                 <a:pPr algn="ctr">
@@ -5827,18 +5667,19 @@
                     <a:spcPts val="3024"/>
                   </a:lnSpc>
                 </a:pPr>
+                <a:endParaRPr/>
               </a:p>
             </p:txBody>
           </p:sp>
         </p:grpSp>
         <p:sp>
           <p:nvSpPr>
-            <p:cNvPr name="Freeform 28" id="28"/>
+            <p:cNvPr id="28" name="Freeform 28"/>
             <p:cNvSpPr/>
             <p:nvPr/>
           </p:nvSpPr>
           <p:spPr>
-            <a:xfrm flipH="false" flipV="false" rot="0">
+            <a:xfrm>
               <a:off x="197640" y="167056"/>
               <a:ext cx="490338" cy="551505"/>
             </a:xfrm>
@@ -5847,9 +5688,9 @@
               <a:gdLst/>
               <a:ahLst/>
               <a:cxnLst/>
-              <a:rect r="r" b="b" t="t" l="l"/>
+              <a:rect l="l" t="t" r="r" b="b"/>
               <a:pathLst>
-                <a:path h="551505" w="490338">
+                <a:path w="490338" h="551505">
                   <a:moveTo>
                     <a:pt x="0" y="0"/>
                   </a:moveTo>
@@ -5870,15 +5711,15 @@
               </a:pathLst>
             </a:custGeom>
             <a:blipFill>
-              <a:blip r:embed="rId17">
+              <a:blip r:embed="rId15">
                 <a:extLst>
                   <a:ext uri="{96DAC541-7B7A-43D3-8B79-37D633B846F1}">
-                    <asvg:svgBlip xmlns:asvg="http://schemas.microsoft.com/office/drawing/2016/SVG/main" r:embed="rId18"/>
+                    <asvg:svgBlip xmlns:asvg="http://schemas.microsoft.com/office/drawing/2016/SVG/main" r:embed="rId16"/>
                   </a:ext>
                 </a:extLst>
               </a:blip>
               <a:stretch>
-                <a:fillRect l="0" t="0" r="0" b="0"/>
+                <a:fillRect/>
               </a:stretch>
             </a:blipFill>
           </p:spPr>
@@ -5886,12 +5727,12 @@
       </p:grpSp>
       <p:grpSp>
         <p:nvGrpSpPr>
-          <p:cNvPr name="Group 29" id="29"/>
+          <p:cNvPr id="29" name="Group 29"/>
           <p:cNvGrpSpPr/>
           <p:nvPr/>
         </p:nvGrpSpPr>
         <p:grpSpPr>
-          <a:xfrm rot="0">
+          <a:xfrm>
             <a:off x="1466773" y="8238787"/>
             <a:ext cx="664213" cy="664213"/>
             <a:chOff x="0" y="0"/>
@@ -5900,12 +5741,12 @@
         </p:grpSpPr>
         <p:grpSp>
           <p:nvGrpSpPr>
-            <p:cNvPr name="Group 30" id="30"/>
+            <p:cNvPr id="30" name="Group 30"/>
             <p:cNvGrpSpPr/>
             <p:nvPr/>
           </p:nvGrpSpPr>
           <p:grpSpPr>
-            <a:xfrm rot="0">
+            <a:xfrm>
               <a:off x="0" y="0"/>
               <a:ext cx="885617" cy="885617"/>
               <a:chOff x="0" y="0"/>
@@ -5914,12 +5755,12 @@
           </p:grpSpPr>
           <p:sp>
             <p:nvSpPr>
-              <p:cNvPr name="Freeform 31" id="31"/>
+              <p:cNvPr id="31" name="Freeform 31"/>
               <p:cNvSpPr/>
               <p:nvPr/>
             </p:nvSpPr>
             <p:spPr>
-              <a:xfrm flipH="false" flipV="false" rot="0">
+              <a:xfrm>
                 <a:off x="0" y="0"/>
                 <a:ext cx="812800" cy="812800"/>
               </a:xfrm>
@@ -5928,9 +5769,9 @@
                 <a:gdLst/>
                 <a:ahLst/>
                 <a:cxnLst/>
-                <a:rect r="r" b="b" t="t" l="l"/>
+                <a:rect l="l" t="t" r="r" b="b"/>
                 <a:pathLst>
-                  <a:path h="812800" w="812800">
+                  <a:path w="812800" h="812800">
                     <a:moveTo>
                       <a:pt x="406400" y="0"/>
                     </a:moveTo>
@@ -5965,8 +5806,8 @@
           </p:sp>
           <p:sp>
             <p:nvSpPr>
-              <p:cNvPr name="TextBox 32" id="32"/>
-              <p:cNvSpPr txBox="true"/>
+              <p:cNvPr id="32" name="TextBox 32"/>
+              <p:cNvSpPr txBox="1"/>
               <p:nvPr/>
             </p:nvSpPr>
             <p:spPr>
@@ -5979,7 +5820,7 @@
               </a:prstGeom>
             </p:spPr>
             <p:txBody>
-              <a:bodyPr anchor="ctr" rtlCol="false" tIns="50800" lIns="50800" bIns="50800" rIns="50800"/>
+              <a:bodyPr lIns="50800" tIns="50800" rIns="50800" bIns="50800" rtlCol="0" anchor="ctr"/>
               <a:lstStyle/>
               <a:p>
                 <a:pPr algn="ctr">
@@ -5987,18 +5828,19 @@
                     <a:spcPts val="3024"/>
                   </a:lnSpc>
                 </a:pPr>
+                <a:endParaRPr/>
               </a:p>
             </p:txBody>
           </p:sp>
         </p:grpSp>
         <p:sp>
           <p:nvSpPr>
-            <p:cNvPr name="Freeform 33" id="33"/>
+            <p:cNvPr id="33" name="Freeform 33"/>
             <p:cNvSpPr/>
             <p:nvPr/>
           </p:nvSpPr>
           <p:spPr>
-            <a:xfrm flipH="false" flipV="false" rot="0">
+            <a:xfrm>
               <a:off x="155110" y="193818"/>
               <a:ext cx="575398" cy="497981"/>
             </a:xfrm>
@@ -6007,9 +5849,9 @@
               <a:gdLst/>
               <a:ahLst/>
               <a:cxnLst/>
-              <a:rect r="r" b="b" t="t" l="l"/>
+              <a:rect l="l" t="t" r="r" b="b"/>
               <a:pathLst>
-                <a:path h="497981" w="575398">
+                <a:path w="575398" h="497981">
                   <a:moveTo>
                     <a:pt x="0" y="0"/>
                   </a:moveTo>
@@ -6030,15 +5872,15 @@
               </a:pathLst>
             </a:custGeom>
             <a:blipFill>
-              <a:blip r:embed="rId19">
+              <a:blip r:embed="rId17">
                 <a:extLst>
                   <a:ext uri="{96DAC541-7B7A-43D3-8B79-37D633B846F1}">
-                    <asvg:svgBlip xmlns:asvg="http://schemas.microsoft.com/office/drawing/2016/SVG/main" r:embed="rId20"/>
+                    <asvg:svgBlip xmlns:asvg="http://schemas.microsoft.com/office/drawing/2016/SVG/main" r:embed="rId18"/>
                   </a:ext>
                 </a:extLst>
               </a:blip>
               <a:stretch>
-                <a:fillRect l="0" t="0" r="0" b="0"/>
+                <a:fillRect/>
               </a:stretch>
             </a:blipFill>
           </p:spPr>
@@ -6046,12 +5888,12 @@
       </p:grpSp>
       <p:grpSp>
         <p:nvGrpSpPr>
-          <p:cNvPr name="Group 34" id="34"/>
+          <p:cNvPr id="34" name="Group 34"/>
           <p:cNvGrpSpPr/>
           <p:nvPr/>
         </p:nvGrpSpPr>
         <p:grpSpPr>
-          <a:xfrm rot="0">
+          <a:xfrm>
             <a:off x="2311687" y="4501225"/>
             <a:ext cx="14386131" cy="4430350"/>
             <a:chOff x="0" y="0"/>
@@ -6060,12 +5902,12 @@
         </p:grpSpPr>
         <p:sp>
           <p:nvSpPr>
-            <p:cNvPr name="TextBox 35" id="35"/>
-            <p:cNvSpPr txBox="true"/>
+            <p:cNvPr id="35" name="TextBox 35"/>
+            <p:cNvSpPr txBox="1"/>
             <p:nvPr/>
           </p:nvSpPr>
           <p:spPr>
-            <a:xfrm rot="0">
+            <a:xfrm>
               <a:off x="0" y="-47625"/>
               <a:ext cx="19181508" cy="5883880"/>
             </a:xfrm>
@@ -6074,7 +5916,7 @@
             </a:prstGeom>
           </p:spPr>
           <p:txBody>
-            <a:bodyPr anchor="t" rtlCol="false" tIns="0" lIns="0" bIns="0" rIns="0">
+            <a:bodyPr lIns="0" tIns="0" rIns="0" bIns="0" rtlCol="0" anchor="t">
               <a:spAutoFit/>
             </a:bodyPr>
             <a:lstStyle/>
@@ -6084,6 +5926,7 @@
                   <a:spcPts val="4472"/>
                 </a:lnSpc>
               </a:pPr>
+              <a:endParaRPr/>
             </a:p>
             <a:p>
               <a:pPr algn="just">
@@ -6110,6 +5953,15 @@
                   <a:spcPts val="4313"/>
                 </a:lnSpc>
               </a:pPr>
+              <a:endParaRPr lang="en-US" sz="3451">
+                <a:solidFill>
+                  <a:srgbClr val="0B533D"/>
+                </a:solidFill>
+                <a:latin typeface="Cambria"/>
+                <a:ea typeface="Cambria"/>
+                <a:cs typeface="Cambria"/>
+                <a:sym typeface="Cambria"/>
+              </a:endParaRPr>
             </a:p>
             <a:p>
               <a:pPr algn="just">
@@ -6136,6 +5988,15 @@
                   <a:spcPts val="4313"/>
                 </a:lnSpc>
               </a:pPr>
+              <a:endParaRPr lang="en-US" sz="3451">
+                <a:solidFill>
+                  <a:srgbClr val="0B533D"/>
+                </a:solidFill>
+                <a:latin typeface="Cambria"/>
+                <a:ea typeface="Cambria"/>
+                <a:cs typeface="Cambria"/>
+                <a:sym typeface="Cambria"/>
+              </a:endParaRPr>
             </a:p>
             <a:p>
               <a:pPr algn="l">
@@ -6162,6 +6023,15 @@
                   <a:spcPts val="4472"/>
                 </a:lnSpc>
               </a:pPr>
+              <a:endParaRPr lang="en-US" sz="3451">
+                <a:solidFill>
+                  <a:srgbClr val="0B533D"/>
+                </a:solidFill>
+                <a:latin typeface="Cambria"/>
+                <a:ea typeface="Cambria"/>
+                <a:cs typeface="Cambria"/>
+                <a:sym typeface="Cambria"/>
+              </a:endParaRPr>
             </a:p>
             <a:p>
               <a:pPr algn="l">
@@ -6186,7 +6056,7 @@
         </p:sp>
         <p:sp>
           <p:nvSpPr>
-            <p:cNvPr name="AutoShape 36" id="36"/>
+            <p:cNvPr id="36" name="AutoShape 36"/>
             <p:cNvSpPr/>
             <p:nvPr/>
           </p:nvSpPr>
@@ -6198,19 +6068,19 @@
             <a:prstGeom prst="line">
               <a:avLst/>
             </a:prstGeom>
-            <a:ln cap="flat" w="38100">
+            <a:ln w="38100" cap="flat">
               <a:solidFill>
                 <a:srgbClr val="DDE7DF"/>
               </a:solidFill>
               <a:prstDash val="solid"/>
-              <a:headEnd type="none" len="sm" w="sm"/>
-              <a:tailEnd type="none" len="sm" w="sm"/>
+              <a:headEnd type="none" w="sm" len="sm"/>
+              <a:tailEnd type="none" w="sm" len="sm"/>
             </a:ln>
           </p:spPr>
         </p:sp>
         <p:sp>
           <p:nvSpPr>
-            <p:cNvPr name="AutoShape 37" id="37"/>
+            <p:cNvPr id="37" name="AutoShape 37"/>
             <p:cNvSpPr/>
             <p:nvPr/>
           </p:nvSpPr>
@@ -6222,19 +6092,19 @@
             <a:prstGeom prst="line">
               <a:avLst/>
             </a:prstGeom>
-            <a:ln cap="flat" w="38100">
+            <a:ln w="38100" cap="flat">
               <a:solidFill>
                 <a:srgbClr val="DDE7DF"/>
               </a:solidFill>
               <a:prstDash val="solid"/>
-              <a:headEnd type="none" len="sm" w="sm"/>
-              <a:tailEnd type="none" len="sm" w="sm"/>
+              <a:headEnd type="none" w="sm" len="sm"/>
+              <a:tailEnd type="none" w="sm" len="sm"/>
             </a:ln>
           </p:spPr>
         </p:sp>
         <p:sp>
           <p:nvSpPr>
-            <p:cNvPr name="AutoShape 38" id="38"/>
+            <p:cNvPr id="38" name="AutoShape 38"/>
             <p:cNvSpPr/>
             <p:nvPr/>
           </p:nvSpPr>
@@ -6246,19 +6116,19 @@
             <a:prstGeom prst="line">
               <a:avLst/>
             </a:prstGeom>
-            <a:ln cap="flat" w="38100">
+            <a:ln w="38100" cap="flat">
               <a:solidFill>
                 <a:srgbClr val="DDE7DF"/>
               </a:solidFill>
               <a:prstDash val="solid"/>
-              <a:headEnd type="none" len="sm" w="sm"/>
-              <a:tailEnd type="none" len="sm" w="sm"/>
+              <a:headEnd type="none" w="sm" len="sm"/>
+              <a:tailEnd type="none" w="sm" len="sm"/>
             </a:ln>
           </p:spPr>
         </p:sp>
         <p:sp>
           <p:nvSpPr>
-            <p:cNvPr name="AutoShape 39" id="39"/>
+            <p:cNvPr id="39" name="AutoShape 39"/>
             <p:cNvSpPr/>
             <p:nvPr/>
           </p:nvSpPr>
@@ -6270,20 +6140,20 @@
             <a:prstGeom prst="line">
               <a:avLst/>
             </a:prstGeom>
-            <a:ln cap="flat" w="38100">
+            <a:ln w="38100" cap="flat">
               <a:solidFill>
                 <a:srgbClr val="DDE7DF"/>
               </a:solidFill>
               <a:prstDash val="solid"/>
-              <a:headEnd type="none" len="sm" w="sm"/>
-              <a:tailEnd type="none" len="sm" w="sm"/>
+              <a:headEnd type="none" w="sm" len="sm"/>
+              <a:tailEnd type="none" w="sm" len="sm"/>
             </a:ln>
           </p:spPr>
         </p:sp>
       </p:grpSp>
       <p:sp>
         <p:nvSpPr>
-          <p:cNvPr name="AutoShape 40" id="40"/>
+          <p:cNvPr id="40" name="AutoShape 40"/>
           <p:cNvSpPr/>
           <p:nvPr/>
         </p:nvSpPr>
@@ -6295,33 +6165,33 @@
           <a:prstGeom prst="line">
             <a:avLst/>
           </a:prstGeom>
-          <a:ln cap="rnd" w="47625">
+          <a:ln w="47625" cap="rnd">
             <a:solidFill>
               <a:srgbClr val="045340"/>
             </a:solidFill>
             <a:prstDash val="solid"/>
-            <a:headEnd type="none" len="sm" w="sm"/>
-            <a:tailEnd type="none" len="sm" w="sm"/>
+            <a:headEnd type="none" w="sm" len="sm"/>
+            <a:tailEnd type="none" w="sm" len="sm"/>
           </a:ln>
         </p:spPr>
       </p:sp>
       <p:sp>
         <p:nvSpPr>
-          <p:cNvPr name="TextBox 41" id="41"/>
-          <p:cNvSpPr txBox="true"/>
+          <p:cNvPr id="41" name="TextBox 41"/>
+          <p:cNvSpPr txBox="1"/>
           <p:nvPr/>
         </p:nvSpPr>
         <p:spPr>
-          <a:xfrm rot="0">
+          <a:xfrm>
             <a:off x="6208852" y="9703384"/>
-            <a:ext cx="5346630" cy="453466"/>
+            <a:ext cx="6516548" cy="415370"/>
           </a:xfrm>
           <a:prstGeom prst="rect">
             <a:avLst/>
           </a:prstGeom>
         </p:spPr>
         <p:txBody>
-          <a:bodyPr anchor="t" rtlCol="false" tIns="0" lIns="0" bIns="0" rIns="0">
+          <a:bodyPr wrap="square" lIns="0" tIns="0" rIns="0" bIns="0" rtlCol="0" anchor="t">
             <a:spAutoFit/>
           </a:bodyPr>
           <a:lstStyle/>
@@ -6332,7 +6202,7 @@
               </a:lnSpc>
             </a:pPr>
             <a:r>
-              <a:rPr lang="en-US" sz="2700">
+              <a:rPr lang="en-US" sz="2700" dirty="0">
                 <a:solidFill>
                   <a:srgbClr val="FFFFFF"/>
                 </a:solidFill>
@@ -6341,28 +6211,28 @@
                 <a:cs typeface="Cambria"/>
                 <a:sym typeface="Cambria"/>
               </a:rPr>
-              <a:t>SRCAS HACKATHON - 3.0 template</a:t>
-            </a:r>
-          </a:p>
-        </p:txBody>
-      </p:sp>
-      <p:sp>
-        <p:nvSpPr>
-          <p:cNvPr name="TextBox 42" id="42"/>
-          <p:cNvSpPr txBox="true"/>
+              <a:t>HACKATHON - 2027 template</a:t>
+            </a:r>
+          </a:p>
+        </p:txBody>
+      </p:sp>
+      <p:sp>
+        <p:nvSpPr>
+          <p:cNvPr id="42" name="TextBox 42"/>
+          <p:cNvSpPr txBox="1"/>
           <p:nvPr/>
         </p:nvSpPr>
         <p:spPr>
-          <a:xfrm rot="0">
+          <a:xfrm>
             <a:off x="2591033" y="2388026"/>
-            <a:ext cx="15449688" cy="854042"/>
+            <a:ext cx="15449688" cy="803618"/>
           </a:xfrm>
           <a:prstGeom prst="rect">
             <a:avLst/>
           </a:prstGeom>
         </p:spPr>
         <p:txBody>
-          <a:bodyPr anchor="t" rtlCol="false" tIns="0" lIns="0" bIns="0" rIns="0">
+          <a:bodyPr lIns="0" tIns="0" rIns="0" bIns="0" rtlCol="0" anchor="t">
             <a:spAutoFit/>
           </a:bodyPr>
           <a:lstStyle/>
@@ -6373,7 +6243,7 @@
               </a:lnSpc>
             </a:pPr>
             <a:r>
-              <a:rPr lang="en-US" b="true" sz="4800" spc="240">
+              <a:rPr lang="en-US" sz="4800" b="1" spc="240" dirty="0">
                 <a:solidFill>
                   <a:srgbClr val="045340"/>
                 </a:solidFill>
@@ -6382,31 +6252,19 @@
                 <a:cs typeface="Cambria Bold"/>
                 <a:sym typeface="Cambria Bold"/>
               </a:rPr>
-              <a:t>SRCAS H</a:t>
-            </a:r>
-            <a:r>
-              <a:rPr lang="en-US" b="true" sz="4800" spc="240">
-                <a:solidFill>
-                  <a:srgbClr val="045340"/>
-                </a:solidFill>
-                <a:latin typeface="Cambria Bold"/>
-                <a:ea typeface="Cambria Bold"/>
-                <a:cs typeface="Cambria Bold"/>
-                <a:sym typeface="Cambria Bold"/>
-              </a:rPr>
-              <a:t>ACKATHON 3.0</a:t>
-            </a:r>
-          </a:p>
-        </p:txBody>
-      </p:sp>
-      <p:sp>
-        <p:nvSpPr>
-          <p:cNvPr name="TextBox 43" id="43"/>
-          <p:cNvSpPr txBox="true"/>
+              <a:t>HACKATHON 2027</a:t>
+            </a:r>
+          </a:p>
+        </p:txBody>
+      </p:sp>
+      <p:sp>
+        <p:nvSpPr>
+          <p:cNvPr id="43" name="TextBox 43"/>
+          <p:cNvSpPr txBox="1"/>
           <p:nvPr/>
         </p:nvSpPr>
         <p:spPr>
-          <a:xfrm rot="0">
+          <a:xfrm>
             <a:off x="2591033" y="3427218"/>
             <a:ext cx="15449688" cy="358279"/>
           </a:xfrm>
@@ -6415,7 +6273,7 @@
           </a:prstGeom>
         </p:spPr>
         <p:txBody>
-          <a:bodyPr anchor="t" rtlCol="false" tIns="0" lIns="0" bIns="0" rIns="0">
+          <a:bodyPr lIns="0" tIns="0" rIns="0" bIns="0" rtlCol="0" anchor="t">
             <a:spAutoFit/>
           </a:bodyPr>
           <a:lstStyle/>
@@ -6497,7 +6355,7 @@
 </file>
 
 <file path=ppt/slides/slide2.xml><?xml version="1.0" encoding="utf-8"?>
-<p:sld xmlns:p="http://schemas.openxmlformats.org/presentationml/2006/main" xmlns:a="http://schemas.openxmlformats.org/drawingml/2006/main" xmlns:r="http://schemas.openxmlformats.org/officeDocument/2006/relationships">
+<p:sld xmlns:a="http://schemas.openxmlformats.org/drawingml/2006/main" xmlns:r="http://schemas.openxmlformats.org/officeDocument/2006/relationships" xmlns:p="http://schemas.openxmlformats.org/presentationml/2006/main">
   <p:cSld>
     <p:spTree>
       <p:nvGrpSpPr>
@@ -6515,7 +6373,7 @@
       </p:grpSpPr>
       <p:grpSp>
         <p:nvGrpSpPr>
-          <p:cNvPr name="Group 2" id="2"/>
+          <p:cNvPr id="2" name="Group 2"/>
           <p:cNvGrpSpPr/>
           <p:nvPr/>
         </p:nvGrpSpPr>
@@ -6529,12 +6387,12 @@
         </p:grpSpPr>
         <p:sp>
           <p:nvSpPr>
-            <p:cNvPr name="Freeform 3" id="3"/>
+            <p:cNvPr id="3" name="Freeform 3"/>
             <p:cNvSpPr/>
             <p:nvPr/>
           </p:nvSpPr>
           <p:spPr>
-            <a:xfrm flipH="false" flipV="false" rot="0">
+            <a:xfrm>
               <a:off x="0" y="0"/>
               <a:ext cx="4654169" cy="76200"/>
             </a:xfrm>
@@ -6543,9 +6401,9 @@
               <a:gdLst/>
               <a:ahLst/>
               <a:cxnLst/>
-              <a:rect r="r" b="b" t="t" l="l"/>
+              <a:rect l="l" t="t" r="r" b="b"/>
               <a:pathLst>
-                <a:path h="76200" w="4654169">
+                <a:path w="4654169" h="76200">
                   <a:moveTo>
                     <a:pt x="0" y="0"/>
                   </a:moveTo>
@@ -6560,7 +6418,7 @@
                 <a:alphaModFix amt="0"/>
               </a:blip>
               <a:stretch>
-                <a:fillRect l="0" t="-1140103" r="0" b="-1140103"/>
+                <a:fillRect t="-1140103" b="-1140103"/>
               </a:stretch>
             </a:blipFill>
             <a:ln w="57150" cap="sq">
@@ -6575,12 +6433,12 @@
       </p:grpSp>
       <p:sp>
         <p:nvSpPr>
-          <p:cNvPr name="TextBox 4" id="4"/>
-          <p:cNvSpPr txBox="true"/>
+          <p:cNvPr id="4" name="TextBox 4"/>
+          <p:cNvSpPr txBox="1"/>
           <p:nvPr/>
         </p:nvSpPr>
         <p:spPr>
-          <a:xfrm rot="0">
+          <a:xfrm>
             <a:off x="17192777" y="9580493"/>
             <a:ext cx="784803" cy="456448"/>
           </a:xfrm>
@@ -6589,7 +6447,7 @@
           </a:prstGeom>
         </p:spPr>
         <p:txBody>
-          <a:bodyPr anchor="t" rtlCol="false" tIns="0" lIns="0" bIns="0" rIns="0">
+          <a:bodyPr lIns="0" tIns="0" rIns="0" bIns="0" rtlCol="0" anchor="t">
             <a:spAutoFit/>
           </a:bodyPr>
           <a:lstStyle/>
@@ -6616,12 +6474,12 @@
       </p:sp>
       <p:sp>
         <p:nvSpPr>
-          <p:cNvPr name="Freeform 5" id="5"/>
+          <p:cNvPr id="5" name="Freeform 5"/>
           <p:cNvSpPr/>
           <p:nvPr/>
         </p:nvSpPr>
         <p:spPr>
-          <a:xfrm flipH="false" flipV="false" rot="0">
+          <a:xfrm>
             <a:off x="0" y="9424245"/>
             <a:ext cx="18288000" cy="862755"/>
           </a:xfrm>
@@ -6630,9 +6488,9 @@
             <a:gdLst/>
             <a:ahLst/>
             <a:cxnLst/>
-            <a:rect r="r" b="b" t="t" l="l"/>
+            <a:rect l="l" t="t" r="r" b="b"/>
             <a:pathLst>
-              <a:path h="862755" w="18288000">
+              <a:path w="18288000" h="862755">
                 <a:moveTo>
                   <a:pt x="0" y="0"/>
                 </a:moveTo>
@@ -6661,65 +6519,19 @@
               </a:extLst>
             </a:blip>
             <a:stretch>
-              <a:fillRect l="0" t="0" r="0" b="0"/>
+              <a:fillRect/>
             </a:stretch>
           </a:blipFill>
         </p:spPr>
       </p:sp>
       <p:sp>
         <p:nvSpPr>
-          <p:cNvPr name="Freeform 6" id="6"/>
-          <p:cNvSpPr/>
+          <p:cNvPr id="7" name="TextBox 7"/>
+          <p:cNvSpPr txBox="1"/>
           <p:nvPr/>
         </p:nvSpPr>
         <p:spPr>
-          <a:xfrm flipH="false" flipV="false" rot="0">
-            <a:off x="14714122" y="342716"/>
-            <a:ext cx="3263458" cy="982059"/>
-          </a:xfrm>
-          <a:custGeom>
-            <a:avLst/>
-            <a:gdLst/>
-            <a:ahLst/>
-            <a:cxnLst/>
-            <a:rect r="r" b="b" t="t" l="l"/>
-            <a:pathLst>
-              <a:path h="982059" w="3263458">
-                <a:moveTo>
-                  <a:pt x="0" y="0"/>
-                </a:moveTo>
-                <a:lnTo>
-                  <a:pt x="3263458" y="0"/>
-                </a:lnTo>
-                <a:lnTo>
-                  <a:pt x="3263458" y="982059"/>
-                </a:lnTo>
-                <a:lnTo>
-                  <a:pt x="0" y="982059"/>
-                </a:lnTo>
-                <a:lnTo>
-                  <a:pt x="0" y="0"/>
-                </a:lnTo>
-                <a:close/>
-              </a:path>
-            </a:pathLst>
-          </a:custGeom>
-          <a:blipFill>
-            <a:blip r:embed="rId6"/>
-            <a:stretch>
-              <a:fillRect l="0" t="0" r="0" b="0"/>
-            </a:stretch>
-          </a:blipFill>
-        </p:spPr>
-      </p:sp>
-      <p:sp>
-        <p:nvSpPr>
-          <p:cNvPr name="TextBox 7" id="7"/>
-          <p:cNvSpPr txBox="true"/>
-          <p:nvPr/>
-        </p:nvSpPr>
-        <p:spPr>
-          <a:xfrm rot="0">
+          <a:xfrm>
             <a:off x="1028700" y="781850"/>
             <a:ext cx="8301599" cy="1028700"/>
           </a:xfrm>
@@ -6728,7 +6540,7 @@
           </a:prstGeom>
         </p:spPr>
         <p:txBody>
-          <a:bodyPr anchor="t" rtlCol="false" tIns="0" lIns="0" bIns="0" rIns="0">
+          <a:bodyPr lIns="0" tIns="0" rIns="0" bIns="0" rtlCol="0" anchor="t">
             <a:spAutoFit/>
           </a:bodyPr>
           <a:lstStyle/>
@@ -6739,7 +6551,7 @@
               </a:lnSpc>
             </a:pPr>
             <a:r>
-              <a:rPr lang="en-US" sz="5939" b="true">
+              <a:rPr lang="en-US" sz="5939" b="1">
                 <a:solidFill>
                   <a:srgbClr val="000000"/>
                 </a:solidFill>
@@ -6755,12 +6567,12 @@
       </p:sp>
       <p:sp>
         <p:nvSpPr>
-          <p:cNvPr name="TextBox 8" id="8"/>
-          <p:cNvSpPr txBox="true"/>
+          <p:cNvPr id="8" name="TextBox 8"/>
+          <p:cNvSpPr txBox="1"/>
           <p:nvPr/>
         </p:nvSpPr>
         <p:spPr>
-          <a:xfrm rot="0">
+          <a:xfrm>
             <a:off x="1028700" y="2859157"/>
             <a:ext cx="16556479" cy="2546347"/>
           </a:xfrm>
@@ -6769,16 +6581,16 @@
           </a:prstGeom>
         </p:spPr>
         <p:txBody>
-          <a:bodyPr anchor="t" rtlCol="false" tIns="0" lIns="0" bIns="0" rIns="0">
+          <a:bodyPr lIns="0" tIns="0" rIns="0" bIns="0" rtlCol="0" anchor="t">
             <a:spAutoFit/>
           </a:bodyPr>
           <a:lstStyle/>
           <a:p>
-            <a:pPr algn="l" marL="800101" indent="-266700" lvl="2">
+            <a:pPr marL="800101" lvl="2" indent="-266700" algn="l">
               <a:lnSpc>
                 <a:spcPts val="8750"/>
               </a:lnSpc>
-              <a:buAutoNum type="arabicPeriod" startAt="1"/>
+              <a:buAutoNum type="arabicPeriod"/>
             </a:pPr>
             <a:r>
               <a:rPr lang="en-US" sz="3500">
@@ -6794,11 +6606,11 @@
             </a:r>
           </a:p>
           <a:p>
-            <a:pPr algn="l" marL="800101" indent="-266700" lvl="2">
+            <a:pPr marL="800101" lvl="2" indent="-266700" algn="l">
               <a:lnSpc>
                 <a:spcPts val="8750"/>
               </a:lnSpc>
-              <a:buAutoNum type="arabicPeriod" startAt="1"/>
+              <a:buAutoNum type="arabicPeriod"/>
             </a:pPr>
             <a:r>
               <a:rPr lang="en-US" sz="3500">
@@ -6817,32 +6629,32 @@
       </p:sp>
       <p:sp>
         <p:nvSpPr>
-          <p:cNvPr name="TextBox 9" id="9"/>
-          <p:cNvSpPr txBox="true"/>
+          <p:cNvPr id="9" name="TextBox 9"/>
+          <p:cNvSpPr txBox="1"/>
           <p:nvPr/>
         </p:nvSpPr>
         <p:spPr>
-          <a:xfrm rot="0">
+          <a:xfrm>
             <a:off x="6208852" y="9703384"/>
-            <a:ext cx="5346630" cy="453466"/>
+            <a:ext cx="6821348" cy="415370"/>
           </a:xfrm>
           <a:prstGeom prst="rect">
             <a:avLst/>
           </a:prstGeom>
         </p:spPr>
         <p:txBody>
-          <a:bodyPr anchor="t" rtlCol="false" tIns="0" lIns="0" bIns="0" rIns="0">
+          <a:bodyPr wrap="square" lIns="0" tIns="0" rIns="0" bIns="0" rtlCol="0" anchor="t">
             <a:spAutoFit/>
           </a:bodyPr>
           <a:lstStyle/>
           <a:p>
-            <a:pPr algn="l">
+            <a:pPr>
               <a:lnSpc>
                 <a:spcPts val="3499"/>
               </a:lnSpc>
             </a:pPr>
             <a:r>
-              <a:rPr lang="en-US" sz="2700">
+              <a:rPr lang="en-US" sz="2700" dirty="0">
                 <a:solidFill>
                   <a:srgbClr val="FFFFFF"/>
                 </a:solidFill>
@@ -6851,7 +6663,7 @@
                 <a:cs typeface="Cambria"/>
                 <a:sym typeface="Cambria"/>
               </a:rPr>
-              <a:t>SRCAS HACKATHON - 3.0 template</a:t>
+              <a:t>HACKATHON - 2027 template</a:t>
             </a:r>
           </a:p>
         </p:txBody>
@@ -6865,7 +6677,7 @@
 </file>
 
 <file path=ppt/slides/slide3.xml><?xml version="1.0" encoding="utf-8"?>
-<p:sld xmlns:p="http://schemas.openxmlformats.org/presentationml/2006/main" xmlns:a="http://schemas.openxmlformats.org/drawingml/2006/main" xmlns:r="http://schemas.openxmlformats.org/officeDocument/2006/relationships">
+<p:sld xmlns:a="http://schemas.openxmlformats.org/drawingml/2006/main" xmlns:r="http://schemas.openxmlformats.org/officeDocument/2006/relationships" xmlns:p="http://schemas.openxmlformats.org/presentationml/2006/main">
   <p:cSld>
     <p:spTree>
       <p:nvGrpSpPr>
@@ -6883,7 +6695,7 @@
       </p:grpSpPr>
       <p:grpSp>
         <p:nvGrpSpPr>
-          <p:cNvPr name="Group 2" id="2"/>
+          <p:cNvPr id="2" name="Group 2"/>
           <p:cNvGrpSpPr/>
           <p:nvPr/>
         </p:nvGrpSpPr>
@@ -6897,12 +6709,12 @@
         </p:grpSpPr>
         <p:sp>
           <p:nvSpPr>
-            <p:cNvPr name="Freeform 3" id="3"/>
+            <p:cNvPr id="3" name="Freeform 3"/>
             <p:cNvSpPr/>
             <p:nvPr/>
           </p:nvSpPr>
           <p:spPr>
-            <a:xfrm flipH="false" flipV="false" rot="0">
+            <a:xfrm>
               <a:off x="0" y="0"/>
               <a:ext cx="4654169" cy="76200"/>
             </a:xfrm>
@@ -6911,9 +6723,9 @@
               <a:gdLst/>
               <a:ahLst/>
               <a:cxnLst/>
-              <a:rect r="r" b="b" t="t" l="l"/>
+              <a:rect l="l" t="t" r="r" b="b"/>
               <a:pathLst>
-                <a:path h="76200" w="4654169">
+                <a:path w="4654169" h="76200">
                   <a:moveTo>
                     <a:pt x="0" y="0"/>
                   </a:moveTo>
@@ -6928,7 +6740,7 @@
                 <a:alphaModFix amt="0"/>
               </a:blip>
               <a:stretch>
-                <a:fillRect l="0" t="-1140103" r="0" b="-1140103"/>
+                <a:fillRect t="-1140103" b="-1140103"/>
               </a:stretch>
             </a:blipFill>
             <a:ln w="57150" cap="sq">
@@ -6943,12 +6755,12 @@
       </p:grpSp>
       <p:sp>
         <p:nvSpPr>
-          <p:cNvPr name="TextBox 4" id="4"/>
-          <p:cNvSpPr txBox="true"/>
+          <p:cNvPr id="4" name="TextBox 4"/>
+          <p:cNvSpPr txBox="1"/>
           <p:nvPr/>
         </p:nvSpPr>
         <p:spPr>
-          <a:xfrm rot="0">
+          <a:xfrm>
             <a:off x="1028700" y="781850"/>
             <a:ext cx="8301599" cy="1028700"/>
           </a:xfrm>
@@ -6957,7 +6769,7 @@
           </a:prstGeom>
         </p:spPr>
         <p:txBody>
-          <a:bodyPr anchor="t" rtlCol="false" tIns="0" lIns="0" bIns="0" rIns="0">
+          <a:bodyPr lIns="0" tIns="0" rIns="0" bIns="0" rtlCol="0" anchor="t">
             <a:spAutoFit/>
           </a:bodyPr>
           <a:lstStyle/>
@@ -6968,7 +6780,7 @@
               </a:lnSpc>
             </a:pPr>
             <a:r>
-              <a:rPr lang="en-US" sz="5939" b="true">
+              <a:rPr lang="en-US" sz="5939" b="1">
                 <a:solidFill>
                   <a:srgbClr val="000000"/>
                 </a:solidFill>
@@ -6984,12 +6796,12 @@
       </p:sp>
       <p:sp>
         <p:nvSpPr>
-          <p:cNvPr name="TextBox 5" id="5"/>
-          <p:cNvSpPr txBox="true"/>
+          <p:cNvPr id="5" name="TextBox 5"/>
+          <p:cNvSpPr txBox="1"/>
           <p:nvPr/>
         </p:nvSpPr>
         <p:spPr>
-          <a:xfrm rot="0">
+          <a:xfrm>
             <a:off x="17192777" y="9580493"/>
             <a:ext cx="784803" cy="456448"/>
           </a:xfrm>
@@ -6998,7 +6810,7 @@
           </a:prstGeom>
         </p:spPr>
         <p:txBody>
-          <a:bodyPr anchor="t" rtlCol="false" tIns="0" lIns="0" bIns="0" rIns="0">
+          <a:bodyPr lIns="0" tIns="0" rIns="0" bIns="0" rtlCol="0" anchor="t">
             <a:spAutoFit/>
           </a:bodyPr>
           <a:lstStyle/>
@@ -7025,12 +6837,12 @@
       </p:sp>
       <p:sp>
         <p:nvSpPr>
-          <p:cNvPr name="Freeform 6" id="6"/>
+          <p:cNvPr id="6" name="Freeform 6"/>
           <p:cNvSpPr/>
           <p:nvPr/>
         </p:nvSpPr>
         <p:spPr>
-          <a:xfrm flipH="false" flipV="false" rot="0">
+          <a:xfrm>
             <a:off x="0" y="9424245"/>
             <a:ext cx="18288000" cy="862755"/>
           </a:xfrm>
@@ -7039,9 +6851,9 @@
             <a:gdLst/>
             <a:ahLst/>
             <a:cxnLst/>
-            <a:rect r="r" b="b" t="t" l="l"/>
+            <a:rect l="l" t="t" r="r" b="b"/>
             <a:pathLst>
-              <a:path h="862755" w="18288000">
+              <a:path w="18288000" h="862755">
                 <a:moveTo>
                   <a:pt x="0" y="0"/>
                 </a:moveTo>
@@ -7070,39 +6882,39 @@
               </a:extLst>
             </a:blip>
             <a:stretch>
-              <a:fillRect l="0" t="0" r="0" b="0"/>
+              <a:fillRect/>
             </a:stretch>
           </a:blipFill>
         </p:spPr>
       </p:sp>
       <p:sp>
         <p:nvSpPr>
-          <p:cNvPr name="TextBox 7" id="7"/>
-          <p:cNvSpPr txBox="true"/>
+          <p:cNvPr id="7" name="TextBox 7"/>
+          <p:cNvSpPr txBox="1"/>
           <p:nvPr/>
         </p:nvSpPr>
         <p:spPr>
-          <a:xfrm rot="0">
+          <a:xfrm>
             <a:off x="6208852" y="9703384"/>
-            <a:ext cx="5346630" cy="453466"/>
+            <a:ext cx="7354748" cy="415370"/>
           </a:xfrm>
           <a:prstGeom prst="rect">
             <a:avLst/>
           </a:prstGeom>
         </p:spPr>
         <p:txBody>
-          <a:bodyPr anchor="t" rtlCol="false" tIns="0" lIns="0" bIns="0" rIns="0">
+          <a:bodyPr wrap="square" lIns="0" tIns="0" rIns="0" bIns="0" rtlCol="0" anchor="t">
             <a:spAutoFit/>
           </a:bodyPr>
           <a:lstStyle/>
           <a:p>
-            <a:pPr algn="l">
+            <a:pPr>
               <a:lnSpc>
                 <a:spcPts val="3499"/>
               </a:lnSpc>
             </a:pPr>
             <a:r>
-              <a:rPr lang="en-US" sz="2700">
+              <a:rPr lang="en-US" sz="2700" dirty="0">
                 <a:solidFill>
                   <a:srgbClr val="FFFFFF"/>
                 </a:solidFill>
@@ -7111,19 +6923,19 @@
                 <a:cs typeface="Cambria"/>
                 <a:sym typeface="Cambria"/>
               </a:rPr>
-              <a:t>SRCAS HACKATHON - 3.0 template</a:t>
-            </a:r>
-          </a:p>
-        </p:txBody>
-      </p:sp>
-      <p:sp>
-        <p:nvSpPr>
-          <p:cNvPr name="TextBox 8" id="8"/>
-          <p:cNvSpPr txBox="true"/>
+              <a:t>HACKATHON - 2027 template</a:t>
+            </a:r>
+          </a:p>
+        </p:txBody>
+      </p:sp>
+      <p:sp>
+        <p:nvSpPr>
+          <p:cNvPr id="8" name="TextBox 8"/>
+          <p:cNvSpPr txBox="1"/>
           <p:nvPr/>
         </p:nvSpPr>
         <p:spPr>
-          <a:xfrm rot="0">
+          <a:xfrm>
             <a:off x="1028700" y="2573407"/>
             <a:ext cx="16556479" cy="3651247"/>
           </a:xfrm>
@@ -7132,16 +6944,16 @@
           </a:prstGeom>
         </p:spPr>
         <p:txBody>
-          <a:bodyPr anchor="t" rtlCol="false" tIns="0" lIns="0" bIns="0" rIns="0">
+          <a:bodyPr lIns="0" tIns="0" rIns="0" bIns="0" rtlCol="0" anchor="t">
             <a:spAutoFit/>
           </a:bodyPr>
           <a:lstStyle/>
           <a:p>
-            <a:pPr algn="l" marL="800101" indent="-266700" lvl="2">
+            <a:pPr marL="800101" lvl="2" indent="-266700" algn="l">
               <a:lnSpc>
                 <a:spcPts val="8750"/>
               </a:lnSpc>
-              <a:buAutoNum type="arabicPeriod" startAt="1"/>
+              <a:buAutoNum type="arabicPeriod"/>
             </a:pPr>
             <a:r>
               <a:rPr lang="en-US" sz="3500">
@@ -7157,11 +6969,11 @@
             </a:r>
           </a:p>
           <a:p>
-            <a:pPr algn="l" marL="800101" indent="-266700" lvl="2">
+            <a:pPr marL="800101" lvl="2" indent="-266700" algn="l">
               <a:lnSpc>
                 <a:spcPts val="8750"/>
               </a:lnSpc>
-              <a:buAutoNum type="arabicPeriod" startAt="1"/>
+              <a:buAutoNum type="arabicPeriod"/>
             </a:pPr>
             <a:r>
               <a:rPr lang="en-US" sz="3500">
@@ -7178,52 +6990,6 @@
           </a:p>
         </p:txBody>
       </p:sp>
-      <p:sp>
-        <p:nvSpPr>
-          <p:cNvPr name="Freeform 9" id="9"/>
-          <p:cNvSpPr/>
-          <p:nvPr/>
-        </p:nvSpPr>
-        <p:spPr>
-          <a:xfrm flipH="false" flipV="false" rot="0">
-            <a:off x="14714122" y="342716"/>
-            <a:ext cx="3263458" cy="982059"/>
-          </a:xfrm>
-          <a:custGeom>
-            <a:avLst/>
-            <a:gdLst/>
-            <a:ahLst/>
-            <a:cxnLst/>
-            <a:rect r="r" b="b" t="t" l="l"/>
-            <a:pathLst>
-              <a:path h="982059" w="3263458">
-                <a:moveTo>
-                  <a:pt x="0" y="0"/>
-                </a:moveTo>
-                <a:lnTo>
-                  <a:pt x="3263458" y="0"/>
-                </a:lnTo>
-                <a:lnTo>
-                  <a:pt x="3263458" y="982059"/>
-                </a:lnTo>
-                <a:lnTo>
-                  <a:pt x="0" y="982059"/>
-                </a:lnTo>
-                <a:lnTo>
-                  <a:pt x="0" y="0"/>
-                </a:lnTo>
-                <a:close/>
-              </a:path>
-            </a:pathLst>
-          </a:custGeom>
-          <a:blipFill>
-            <a:blip r:embed="rId6"/>
-            <a:stretch>
-              <a:fillRect l="0" t="0" r="0" b="0"/>
-            </a:stretch>
-          </a:blipFill>
-        </p:spPr>
-      </p:sp>
     </p:spTree>
   </p:cSld>
   <p:clrMapOvr>
@@ -7233,7 +6999,7 @@
 </file>
 
 <file path=ppt/slides/slide4.xml><?xml version="1.0" encoding="utf-8"?>
-<p:sld xmlns:p="http://schemas.openxmlformats.org/presentationml/2006/main" xmlns:a="http://schemas.openxmlformats.org/drawingml/2006/main" xmlns:r="http://schemas.openxmlformats.org/officeDocument/2006/relationships">
+<p:sld xmlns:a="http://schemas.openxmlformats.org/drawingml/2006/main" xmlns:r="http://schemas.openxmlformats.org/officeDocument/2006/relationships" xmlns:p="http://schemas.openxmlformats.org/presentationml/2006/main">
   <p:cSld>
     <p:spTree>
       <p:nvGrpSpPr>
@@ -7251,12 +7017,12 @@
       </p:grpSpPr>
       <p:grpSp>
         <p:nvGrpSpPr>
-          <p:cNvPr name="Group 2" id="2"/>
+          <p:cNvPr id="2" name="Group 2"/>
           <p:cNvGrpSpPr/>
           <p:nvPr/>
         </p:nvGrpSpPr>
         <p:grpSpPr>
-          <a:xfrm rot="0">
+          <a:xfrm>
             <a:off x="1124560" y="1816284"/>
             <a:ext cx="3850062" cy="57150"/>
             <a:chOff x="0" y="0"/>
@@ -7265,12 +7031,12 @@
         </p:grpSpPr>
         <p:sp>
           <p:nvSpPr>
-            <p:cNvPr name="Freeform 3" id="3"/>
+            <p:cNvPr id="3" name="Freeform 3"/>
             <p:cNvSpPr/>
             <p:nvPr/>
           </p:nvSpPr>
           <p:spPr>
-            <a:xfrm flipH="false" flipV="false" rot="0">
+            <a:xfrm>
               <a:off x="0" y="0"/>
               <a:ext cx="5133467" cy="76200"/>
             </a:xfrm>
@@ -7279,9 +7045,9 @@
               <a:gdLst/>
               <a:ahLst/>
               <a:cxnLst/>
-              <a:rect r="r" b="b" t="t" l="l"/>
+              <a:rect l="l" t="t" r="r" b="b"/>
               <a:pathLst>
-                <a:path h="76200" w="5133467">
+                <a:path w="5133467" h="76200">
                   <a:moveTo>
                     <a:pt x="0" y="0"/>
                   </a:moveTo>
@@ -7296,7 +7062,7 @@
                 <a:alphaModFix amt="0"/>
               </a:blip>
               <a:stretch>
-                <a:fillRect l="0" t="-1262661" r="0" b="-1262661"/>
+                <a:fillRect t="-1262661" b="-1262661"/>
               </a:stretch>
             </a:blipFill>
             <a:ln w="57150" cap="sq">
@@ -7311,12 +7077,12 @@
       </p:grpSp>
       <p:sp>
         <p:nvSpPr>
-          <p:cNvPr name="TextBox 4" id="4"/>
-          <p:cNvSpPr txBox="true"/>
+          <p:cNvPr id="4" name="TextBox 4"/>
+          <p:cNvSpPr txBox="1"/>
           <p:nvPr/>
         </p:nvSpPr>
         <p:spPr>
-          <a:xfrm rot="0">
+          <a:xfrm>
             <a:off x="1125312" y="585664"/>
             <a:ext cx="8671198" cy="990981"/>
           </a:xfrm>
@@ -7325,7 +7091,7 @@
           </a:prstGeom>
         </p:spPr>
         <p:txBody>
-          <a:bodyPr anchor="t" rtlCol="false" tIns="0" lIns="0" bIns="0" rIns="0">
+          <a:bodyPr lIns="0" tIns="0" rIns="0" bIns="0" rtlCol="0" anchor="t">
             <a:spAutoFit/>
           </a:bodyPr>
           <a:lstStyle/>
@@ -7336,7 +7102,7 @@
               </a:lnSpc>
             </a:pPr>
             <a:r>
-              <a:rPr lang="en-US" sz="3900" b="true">
+              <a:rPr lang="en-US" sz="3900" b="1">
                 <a:solidFill>
                   <a:srgbClr val="000000"/>
                 </a:solidFill>
@@ -7352,12 +7118,12 @@
       </p:sp>
       <p:sp>
         <p:nvSpPr>
-          <p:cNvPr name="TextBox 5" id="5"/>
-          <p:cNvSpPr txBox="true"/>
+          <p:cNvPr id="5" name="TextBox 5"/>
+          <p:cNvSpPr txBox="1"/>
           <p:nvPr/>
         </p:nvSpPr>
         <p:spPr>
-          <a:xfrm rot="0">
+          <a:xfrm>
             <a:off x="17289370" y="9572720"/>
             <a:ext cx="784803" cy="456448"/>
           </a:xfrm>
@@ -7366,7 +7132,7 @@
           </a:prstGeom>
         </p:spPr>
         <p:txBody>
-          <a:bodyPr anchor="t" rtlCol="false" tIns="0" lIns="0" bIns="0" rIns="0">
+          <a:bodyPr lIns="0" tIns="0" rIns="0" bIns="0" rtlCol="0" anchor="t">
             <a:spAutoFit/>
           </a:bodyPr>
           <a:lstStyle/>
@@ -7393,12 +7159,12 @@
       </p:sp>
       <p:sp>
         <p:nvSpPr>
-          <p:cNvPr name="Freeform 6" id="6"/>
+          <p:cNvPr id="6" name="Freeform 6"/>
           <p:cNvSpPr/>
           <p:nvPr/>
         </p:nvSpPr>
         <p:spPr>
-          <a:xfrm flipH="false" flipV="false" rot="0">
+          <a:xfrm>
             <a:off x="0" y="9424245"/>
             <a:ext cx="18288000" cy="862755"/>
           </a:xfrm>
@@ -7407,9 +7173,9 @@
             <a:gdLst/>
             <a:ahLst/>
             <a:cxnLst/>
-            <a:rect r="r" b="b" t="t" l="l"/>
+            <a:rect l="l" t="t" r="r" b="b"/>
             <a:pathLst>
-              <a:path h="862755" w="18288000">
+              <a:path w="18288000" h="862755">
                 <a:moveTo>
                   <a:pt x="0" y="0"/>
                 </a:moveTo>
@@ -7438,39 +7204,39 @@
               </a:extLst>
             </a:blip>
             <a:stretch>
-              <a:fillRect l="0" t="0" r="0" b="0"/>
+              <a:fillRect/>
             </a:stretch>
           </a:blipFill>
         </p:spPr>
       </p:sp>
       <p:sp>
         <p:nvSpPr>
-          <p:cNvPr name="TextBox 7" id="7"/>
-          <p:cNvSpPr txBox="true"/>
+          <p:cNvPr id="7" name="TextBox 7"/>
+          <p:cNvSpPr txBox="1"/>
           <p:nvPr/>
         </p:nvSpPr>
         <p:spPr>
-          <a:xfrm rot="0">
+          <a:xfrm>
             <a:off x="6208852" y="9703384"/>
-            <a:ext cx="5346630" cy="453466"/>
+            <a:ext cx="7430948" cy="415370"/>
           </a:xfrm>
           <a:prstGeom prst="rect">
             <a:avLst/>
           </a:prstGeom>
         </p:spPr>
         <p:txBody>
-          <a:bodyPr anchor="t" rtlCol="false" tIns="0" lIns="0" bIns="0" rIns="0">
+          <a:bodyPr wrap="square" lIns="0" tIns="0" rIns="0" bIns="0" rtlCol="0" anchor="t">
             <a:spAutoFit/>
           </a:bodyPr>
           <a:lstStyle/>
           <a:p>
-            <a:pPr algn="l">
+            <a:pPr>
               <a:lnSpc>
                 <a:spcPts val="3499"/>
               </a:lnSpc>
             </a:pPr>
             <a:r>
-              <a:rPr lang="en-US" sz="2700">
+              <a:rPr lang="en-US" sz="2700" dirty="0">
                 <a:solidFill>
                   <a:srgbClr val="FFFFFF"/>
                 </a:solidFill>
@@ -7479,19 +7245,19 @@
                 <a:cs typeface="Cambria"/>
                 <a:sym typeface="Cambria"/>
               </a:rPr>
-              <a:t>SRCAS HACKATHON - 3.0 template</a:t>
-            </a:r>
-          </a:p>
-        </p:txBody>
-      </p:sp>
-      <p:sp>
-        <p:nvSpPr>
-          <p:cNvPr name="TextBox 8" id="8"/>
-          <p:cNvSpPr txBox="true"/>
+              <a:t>HACKATHON - 2027 template</a:t>
+            </a:r>
+          </a:p>
+        </p:txBody>
+      </p:sp>
+      <p:sp>
+        <p:nvSpPr>
+          <p:cNvPr id="8" name="TextBox 8"/>
+          <p:cNvSpPr txBox="1"/>
           <p:nvPr/>
         </p:nvSpPr>
         <p:spPr>
-          <a:xfrm rot="0">
+          <a:xfrm>
             <a:off x="1028700" y="2573407"/>
             <a:ext cx="16556479" cy="3651247"/>
           </a:xfrm>
@@ -7500,16 +7266,16 @@
           </a:prstGeom>
         </p:spPr>
         <p:txBody>
-          <a:bodyPr anchor="t" rtlCol="false" tIns="0" lIns="0" bIns="0" rIns="0">
+          <a:bodyPr lIns="0" tIns="0" rIns="0" bIns="0" rtlCol="0" anchor="t">
             <a:spAutoFit/>
           </a:bodyPr>
           <a:lstStyle/>
           <a:p>
-            <a:pPr algn="l" marL="800101" indent="-266700" lvl="2">
+            <a:pPr marL="800101" lvl="2" indent="-266700" algn="l">
               <a:lnSpc>
                 <a:spcPts val="8750"/>
               </a:lnSpc>
-              <a:buAutoNum type="arabicPeriod" startAt="1"/>
+              <a:buAutoNum type="arabicPeriod"/>
             </a:pPr>
             <a:r>
               <a:rPr lang="en-US" sz="3500">
@@ -7525,11 +7291,11 @@
             </a:r>
           </a:p>
           <a:p>
-            <a:pPr algn="l" marL="800101" indent="-266700" lvl="2">
+            <a:pPr marL="800101" lvl="2" indent="-266700" algn="l">
               <a:lnSpc>
                 <a:spcPts val="8750"/>
               </a:lnSpc>
-              <a:buAutoNum type="arabicPeriod" startAt="1"/>
+              <a:buAutoNum type="arabicPeriod"/>
             </a:pPr>
             <a:r>
               <a:rPr lang="en-US" sz="3500">
@@ -7545,11 +7311,11 @@
             </a:r>
           </a:p>
           <a:p>
-            <a:pPr algn="l" marL="800101" indent="-266700" lvl="2">
+            <a:pPr marL="800101" lvl="2" indent="-266700" algn="l">
               <a:lnSpc>
                 <a:spcPts val="8750"/>
               </a:lnSpc>
-              <a:buAutoNum type="arabicPeriod" startAt="1"/>
+              <a:buAutoNum type="arabicPeriod"/>
             </a:pPr>
             <a:r>
               <a:rPr lang="en-US" sz="3500">
@@ -7566,52 +7332,6 @@
           </a:p>
         </p:txBody>
       </p:sp>
-      <p:sp>
-        <p:nvSpPr>
-          <p:cNvPr name="Freeform 9" id="9"/>
-          <p:cNvSpPr/>
-          <p:nvPr/>
-        </p:nvSpPr>
-        <p:spPr>
-          <a:xfrm flipH="false" flipV="false" rot="0">
-            <a:off x="14714122" y="342716"/>
-            <a:ext cx="3263458" cy="982059"/>
-          </a:xfrm>
-          <a:custGeom>
-            <a:avLst/>
-            <a:gdLst/>
-            <a:ahLst/>
-            <a:cxnLst/>
-            <a:rect r="r" b="b" t="t" l="l"/>
-            <a:pathLst>
-              <a:path h="982059" w="3263458">
-                <a:moveTo>
-                  <a:pt x="0" y="0"/>
-                </a:moveTo>
-                <a:lnTo>
-                  <a:pt x="3263458" y="0"/>
-                </a:lnTo>
-                <a:lnTo>
-                  <a:pt x="3263458" y="982059"/>
-                </a:lnTo>
-                <a:lnTo>
-                  <a:pt x="0" y="982059"/>
-                </a:lnTo>
-                <a:lnTo>
-                  <a:pt x="0" y="0"/>
-                </a:lnTo>
-                <a:close/>
-              </a:path>
-            </a:pathLst>
-          </a:custGeom>
-          <a:blipFill>
-            <a:blip r:embed="rId6"/>
-            <a:stretch>
-              <a:fillRect l="0" t="0" r="0" b="0"/>
-            </a:stretch>
-          </a:blipFill>
-        </p:spPr>
-      </p:sp>
     </p:spTree>
   </p:cSld>
   <p:clrMapOvr>
@@ -7621,7 +7341,7 @@
 </file>
 
 <file path=ppt/slides/slide5.xml><?xml version="1.0" encoding="utf-8"?>
-<p:sld xmlns:p="http://schemas.openxmlformats.org/presentationml/2006/main" xmlns:a="http://schemas.openxmlformats.org/drawingml/2006/main" xmlns:r="http://schemas.openxmlformats.org/officeDocument/2006/relationships">
+<p:sld xmlns:a="http://schemas.openxmlformats.org/drawingml/2006/main" xmlns:r="http://schemas.openxmlformats.org/officeDocument/2006/relationships" xmlns:p="http://schemas.openxmlformats.org/presentationml/2006/main">
   <p:cSld>
     <p:spTree>
       <p:nvGrpSpPr>
@@ -7639,7 +7359,7 @@
       </p:grpSpPr>
       <p:grpSp>
         <p:nvGrpSpPr>
-          <p:cNvPr name="Group 2" id="2"/>
+          <p:cNvPr id="2" name="Group 2"/>
           <p:cNvGrpSpPr/>
           <p:nvPr/>
         </p:nvGrpSpPr>
@@ -7653,12 +7373,12 @@
         </p:grpSpPr>
         <p:sp>
           <p:nvSpPr>
-            <p:cNvPr name="Freeform 3" id="3"/>
+            <p:cNvPr id="3" name="Freeform 3"/>
             <p:cNvSpPr/>
             <p:nvPr/>
           </p:nvSpPr>
           <p:spPr>
-            <a:xfrm flipH="false" flipV="false" rot="0">
+            <a:xfrm>
               <a:off x="0" y="0"/>
               <a:ext cx="4654296" cy="76200"/>
             </a:xfrm>
@@ -7667,9 +7387,9 @@
               <a:gdLst/>
               <a:ahLst/>
               <a:cxnLst/>
-              <a:rect r="r" b="b" t="t" l="l"/>
+              <a:rect l="l" t="t" r="r" b="b"/>
               <a:pathLst>
-                <a:path h="76200" w="4654296">
+                <a:path w="4654296" h="76200">
                   <a:moveTo>
                     <a:pt x="0" y="0"/>
                   </a:moveTo>
@@ -7684,7 +7404,7 @@
                 <a:alphaModFix amt="0"/>
               </a:blip>
               <a:stretch>
-                <a:fillRect l="0" t="-1140149" r="0" b="-1140149"/>
+                <a:fillRect t="-1140149" b="-1140149"/>
               </a:stretch>
             </a:blipFill>
             <a:ln w="57150" cap="sq">
@@ -7699,12 +7419,12 @@
       </p:grpSp>
       <p:sp>
         <p:nvSpPr>
-          <p:cNvPr name="TextBox 4" id="4"/>
-          <p:cNvSpPr txBox="true"/>
+          <p:cNvPr id="4" name="TextBox 4"/>
+          <p:cNvSpPr txBox="1"/>
           <p:nvPr/>
         </p:nvSpPr>
         <p:spPr>
-          <a:xfrm rot="0">
+          <a:xfrm>
             <a:off x="1125312" y="585664"/>
             <a:ext cx="8671198" cy="990981"/>
           </a:xfrm>
@@ -7713,7 +7433,7 @@
           </a:prstGeom>
         </p:spPr>
         <p:txBody>
-          <a:bodyPr anchor="t" rtlCol="false" tIns="0" lIns="0" bIns="0" rIns="0">
+          <a:bodyPr lIns="0" tIns="0" rIns="0" bIns="0" rtlCol="0" anchor="t">
             <a:spAutoFit/>
           </a:bodyPr>
           <a:lstStyle/>
@@ -7724,7 +7444,7 @@
               </a:lnSpc>
             </a:pPr>
             <a:r>
-              <a:rPr lang="en-US" sz="3900" b="true">
+              <a:rPr lang="en-US" sz="3900" b="1">
                 <a:solidFill>
                   <a:srgbClr val="000000"/>
                 </a:solidFill>
@@ -7740,12 +7460,12 @@
       </p:sp>
       <p:sp>
         <p:nvSpPr>
-          <p:cNvPr name="TextBox 5" id="5"/>
-          <p:cNvSpPr txBox="true"/>
+          <p:cNvPr id="5" name="TextBox 5"/>
+          <p:cNvSpPr txBox="1"/>
           <p:nvPr/>
         </p:nvSpPr>
         <p:spPr>
-          <a:xfrm rot="0">
+          <a:xfrm>
             <a:off x="17289370" y="9572720"/>
             <a:ext cx="784803" cy="456448"/>
           </a:xfrm>
@@ -7754,7 +7474,7 @@
           </a:prstGeom>
         </p:spPr>
         <p:txBody>
-          <a:bodyPr anchor="t" rtlCol="false" tIns="0" lIns="0" bIns="0" rIns="0">
+          <a:bodyPr lIns="0" tIns="0" rIns="0" bIns="0" rtlCol="0" anchor="t">
             <a:spAutoFit/>
           </a:bodyPr>
           <a:lstStyle/>
@@ -7781,12 +7501,12 @@
       </p:sp>
       <p:sp>
         <p:nvSpPr>
-          <p:cNvPr name="Freeform 6" id="6"/>
+          <p:cNvPr id="6" name="Freeform 6"/>
           <p:cNvSpPr/>
           <p:nvPr/>
         </p:nvSpPr>
         <p:spPr>
-          <a:xfrm flipH="false" flipV="false" rot="0">
+          <a:xfrm>
             <a:off x="0" y="9424245"/>
             <a:ext cx="18288000" cy="862755"/>
           </a:xfrm>
@@ -7795,9 +7515,9 @@
             <a:gdLst/>
             <a:ahLst/>
             <a:cxnLst/>
-            <a:rect r="r" b="b" t="t" l="l"/>
+            <a:rect l="l" t="t" r="r" b="b"/>
             <a:pathLst>
-              <a:path h="862755" w="18288000">
+              <a:path w="18288000" h="862755">
                 <a:moveTo>
                   <a:pt x="0" y="0"/>
                 </a:moveTo>
@@ -7826,39 +7546,39 @@
               </a:extLst>
             </a:blip>
             <a:stretch>
-              <a:fillRect l="0" t="0" r="0" b="0"/>
+              <a:fillRect/>
             </a:stretch>
           </a:blipFill>
         </p:spPr>
       </p:sp>
       <p:sp>
         <p:nvSpPr>
-          <p:cNvPr name="TextBox 7" id="7"/>
-          <p:cNvSpPr txBox="true"/>
+          <p:cNvPr id="7" name="TextBox 7"/>
+          <p:cNvSpPr txBox="1"/>
           <p:nvPr/>
         </p:nvSpPr>
         <p:spPr>
-          <a:xfrm rot="0">
+          <a:xfrm>
             <a:off x="6208852" y="9703384"/>
-            <a:ext cx="5346630" cy="453466"/>
+            <a:ext cx="7430948" cy="415370"/>
           </a:xfrm>
           <a:prstGeom prst="rect">
             <a:avLst/>
           </a:prstGeom>
         </p:spPr>
         <p:txBody>
-          <a:bodyPr anchor="t" rtlCol="false" tIns="0" lIns="0" bIns="0" rIns="0">
+          <a:bodyPr wrap="square" lIns="0" tIns="0" rIns="0" bIns="0" rtlCol="0" anchor="t">
             <a:spAutoFit/>
           </a:bodyPr>
           <a:lstStyle/>
           <a:p>
-            <a:pPr algn="l">
+            <a:pPr>
               <a:lnSpc>
                 <a:spcPts val="3499"/>
               </a:lnSpc>
             </a:pPr>
             <a:r>
-              <a:rPr lang="en-US" sz="2700">
+              <a:rPr lang="en-US" sz="2700" dirty="0">
                 <a:solidFill>
                   <a:srgbClr val="FFFFFF"/>
                 </a:solidFill>
@@ -7867,19 +7587,19 @@
                 <a:cs typeface="Cambria"/>
                 <a:sym typeface="Cambria"/>
               </a:rPr>
-              <a:t>SRCAS HACKATHON - 3.0 template</a:t>
-            </a:r>
-          </a:p>
-        </p:txBody>
-      </p:sp>
-      <p:sp>
-        <p:nvSpPr>
-          <p:cNvPr name="TextBox 8" id="8"/>
-          <p:cNvSpPr txBox="true"/>
+              <a:t>HACKATHON - 2027 template</a:t>
+            </a:r>
+          </a:p>
+        </p:txBody>
+      </p:sp>
+      <p:sp>
+        <p:nvSpPr>
+          <p:cNvPr id="8" name="TextBox 8"/>
+          <p:cNvSpPr txBox="1"/>
           <p:nvPr/>
         </p:nvSpPr>
         <p:spPr>
-          <a:xfrm rot="0">
+          <a:xfrm>
             <a:off x="1028700" y="2573407"/>
             <a:ext cx="16556479" cy="2546347"/>
           </a:xfrm>
@@ -7888,16 +7608,16 @@
           </a:prstGeom>
         </p:spPr>
         <p:txBody>
-          <a:bodyPr anchor="t" rtlCol="false" tIns="0" lIns="0" bIns="0" rIns="0">
+          <a:bodyPr lIns="0" tIns="0" rIns="0" bIns="0" rtlCol="0" anchor="t">
             <a:spAutoFit/>
           </a:bodyPr>
           <a:lstStyle/>
           <a:p>
-            <a:pPr algn="l" marL="800101" indent="-266700" lvl="2">
+            <a:pPr marL="800101" lvl="2" indent="-266700" algn="l">
               <a:lnSpc>
                 <a:spcPts val="8750"/>
               </a:lnSpc>
-              <a:buAutoNum type="arabicPeriod" startAt="1"/>
+              <a:buAutoNum type="arabicPeriod"/>
             </a:pPr>
             <a:r>
               <a:rPr lang="en-US" sz="3500">
@@ -7913,11 +7633,11 @@
             </a:r>
           </a:p>
           <a:p>
-            <a:pPr algn="l" marL="800101" indent="-266700" lvl="2">
+            <a:pPr marL="800101" lvl="2" indent="-266700" algn="l">
               <a:lnSpc>
                 <a:spcPts val="8750"/>
               </a:lnSpc>
-              <a:buAutoNum type="arabicPeriod" startAt="1"/>
+              <a:buAutoNum type="arabicPeriod"/>
             </a:pPr>
             <a:r>
               <a:rPr lang="en-US" sz="3500">
@@ -7934,52 +7654,6 @@
           </a:p>
         </p:txBody>
       </p:sp>
-      <p:sp>
-        <p:nvSpPr>
-          <p:cNvPr name="Freeform 9" id="9"/>
-          <p:cNvSpPr/>
-          <p:nvPr/>
-        </p:nvSpPr>
-        <p:spPr>
-          <a:xfrm flipH="false" flipV="false" rot="0">
-            <a:off x="14714122" y="342716"/>
-            <a:ext cx="3263458" cy="982059"/>
-          </a:xfrm>
-          <a:custGeom>
-            <a:avLst/>
-            <a:gdLst/>
-            <a:ahLst/>
-            <a:cxnLst/>
-            <a:rect r="r" b="b" t="t" l="l"/>
-            <a:pathLst>
-              <a:path h="982059" w="3263458">
-                <a:moveTo>
-                  <a:pt x="0" y="0"/>
-                </a:moveTo>
-                <a:lnTo>
-                  <a:pt x="3263458" y="0"/>
-                </a:lnTo>
-                <a:lnTo>
-                  <a:pt x="3263458" y="982059"/>
-                </a:lnTo>
-                <a:lnTo>
-                  <a:pt x="0" y="982059"/>
-                </a:lnTo>
-                <a:lnTo>
-                  <a:pt x="0" y="0"/>
-                </a:lnTo>
-                <a:close/>
-              </a:path>
-            </a:pathLst>
-          </a:custGeom>
-          <a:blipFill>
-            <a:blip r:embed="rId6"/>
-            <a:stretch>
-              <a:fillRect l="0" t="0" r="0" b="0"/>
-            </a:stretch>
-          </a:blipFill>
-        </p:spPr>
-      </p:sp>
     </p:spTree>
   </p:cSld>
   <p:clrMapOvr>
@@ -7989,7 +7663,7 @@
 </file>
 
 <file path=ppt/slides/slide6.xml><?xml version="1.0" encoding="utf-8"?>
-<p:sld xmlns:p="http://schemas.openxmlformats.org/presentationml/2006/main" xmlns:a="http://schemas.openxmlformats.org/drawingml/2006/main" xmlns:r="http://schemas.openxmlformats.org/officeDocument/2006/relationships">
+<p:sld xmlns:a="http://schemas.openxmlformats.org/drawingml/2006/main" xmlns:r="http://schemas.openxmlformats.org/officeDocument/2006/relationships" xmlns:p="http://schemas.openxmlformats.org/presentationml/2006/main">
   <p:cSld>
     <p:spTree>
       <p:nvGrpSpPr>
@@ -8007,7 +7681,7 @@
       </p:grpSpPr>
       <p:grpSp>
         <p:nvGrpSpPr>
-          <p:cNvPr name="Group 2" id="2"/>
+          <p:cNvPr id="2" name="Group 2"/>
           <p:cNvGrpSpPr/>
           <p:nvPr/>
         </p:nvGrpSpPr>
@@ -8021,12 +7695,12 @@
         </p:grpSpPr>
         <p:sp>
           <p:nvSpPr>
-            <p:cNvPr name="Freeform 3" id="3"/>
+            <p:cNvPr id="3" name="Freeform 3"/>
             <p:cNvSpPr/>
             <p:nvPr/>
           </p:nvSpPr>
           <p:spPr>
-            <a:xfrm flipH="false" flipV="false" rot="0">
+            <a:xfrm>
               <a:off x="0" y="0"/>
               <a:ext cx="4654169" cy="76200"/>
             </a:xfrm>
@@ -8035,9 +7709,9 @@
               <a:gdLst/>
               <a:ahLst/>
               <a:cxnLst/>
-              <a:rect r="r" b="b" t="t" l="l"/>
+              <a:rect l="l" t="t" r="r" b="b"/>
               <a:pathLst>
-                <a:path h="76200" w="4654169">
+                <a:path w="4654169" h="76200">
                   <a:moveTo>
                     <a:pt x="0" y="0"/>
                   </a:moveTo>
@@ -8052,7 +7726,7 @@
                 <a:alphaModFix amt="0"/>
               </a:blip>
               <a:stretch>
-                <a:fillRect l="0" t="-1140103" r="0" b="-1140103"/>
+                <a:fillRect t="-1140103" b="-1140103"/>
               </a:stretch>
             </a:blipFill>
             <a:ln w="57150" cap="sq">
@@ -8067,12 +7741,12 @@
       </p:grpSp>
       <p:sp>
         <p:nvSpPr>
-          <p:cNvPr name="TextBox 4" id="4"/>
-          <p:cNvSpPr txBox="true"/>
+          <p:cNvPr id="4" name="TextBox 4"/>
+          <p:cNvSpPr txBox="1"/>
           <p:nvPr/>
         </p:nvSpPr>
         <p:spPr>
-          <a:xfrm rot="0">
+          <a:xfrm>
             <a:off x="1446038" y="1223343"/>
             <a:ext cx="9926260" cy="1011545"/>
           </a:xfrm>
@@ -8081,7 +7755,7 @@
           </a:prstGeom>
         </p:spPr>
         <p:txBody>
-          <a:bodyPr anchor="t" rtlCol="false" tIns="0" lIns="0" bIns="0" rIns="0">
+          <a:bodyPr lIns="0" tIns="0" rIns="0" bIns="0" rtlCol="0" anchor="t">
             <a:spAutoFit/>
           </a:bodyPr>
           <a:lstStyle/>
@@ -8092,7 +7766,7 @@
               </a:lnSpc>
             </a:pPr>
             <a:r>
-              <a:rPr lang="en-US" sz="6600" b="true">
+              <a:rPr lang="en-US" sz="6600" b="1">
                 <a:solidFill>
                   <a:srgbClr val="000000"/>
                 </a:solidFill>
@@ -8108,12 +7782,12 @@
       </p:sp>
       <p:sp>
         <p:nvSpPr>
-          <p:cNvPr name="TextBox 5" id="5"/>
-          <p:cNvSpPr txBox="true"/>
+          <p:cNvPr id="5" name="TextBox 5"/>
+          <p:cNvSpPr txBox="1"/>
           <p:nvPr/>
         </p:nvSpPr>
         <p:spPr>
-          <a:xfrm rot="0">
+          <a:xfrm>
             <a:off x="1446038" y="2292525"/>
             <a:ext cx="5448252" cy="6965775"/>
           </a:xfrm>
@@ -8122,7 +7796,7 @@
           </a:prstGeom>
         </p:spPr>
         <p:txBody>
-          <a:bodyPr anchor="t" rtlCol="false" tIns="0" lIns="0" bIns="0" rIns="0">
+          <a:bodyPr lIns="0" tIns="0" rIns="0" bIns="0" rtlCol="0" anchor="t">
             <a:spAutoFit/>
           </a:bodyPr>
           <a:lstStyle/>
@@ -8133,7 +7807,7 @@
               </a:lnSpc>
             </a:pPr>
             <a:r>
-              <a:rPr lang="en-US" sz="2662" b="true">
+              <a:rPr lang="en-US" sz="2662" b="1">
                 <a:solidFill>
                   <a:srgbClr val="0B533D"/>
                 </a:solidFill>
@@ -8171,7 +7845,7 @@
               </a:lnSpc>
             </a:pPr>
             <a:r>
-              <a:rPr lang="en-US" sz="2662" b="true">
+              <a:rPr lang="en-US" sz="2662" b="1">
                 <a:solidFill>
                   <a:srgbClr val="0B533D"/>
                 </a:solidFill>
@@ -8209,7 +7883,7 @@
               </a:lnSpc>
             </a:pPr>
             <a:r>
-              <a:rPr lang="en-US" sz="2662" b="true">
+              <a:rPr lang="en-US" sz="2662" b="1">
                 <a:solidFill>
                   <a:srgbClr val="0B533D"/>
                 </a:solidFill>
@@ -8247,7 +7921,7 @@
               </a:lnSpc>
             </a:pPr>
             <a:r>
-              <a:rPr lang="en-US" sz="2662" b="true">
+              <a:rPr lang="en-US" sz="2662" b="1">
                 <a:solidFill>
                   <a:srgbClr val="0B533D"/>
                 </a:solidFill>
@@ -8282,12 +7956,12 @@
       </p:sp>
       <p:sp>
         <p:nvSpPr>
-          <p:cNvPr name="Freeform 6" id="6"/>
+          <p:cNvPr id="6" name="Freeform 6"/>
           <p:cNvSpPr/>
           <p:nvPr/>
         </p:nvSpPr>
         <p:spPr>
-          <a:xfrm flipH="false" flipV="false" rot="0">
+          <a:xfrm>
             <a:off x="0" y="9424245"/>
             <a:ext cx="18288000" cy="862755"/>
           </a:xfrm>
@@ -8296,9 +7970,9 @@
             <a:gdLst/>
             <a:ahLst/>
             <a:cxnLst/>
-            <a:rect r="r" b="b" t="t" l="l"/>
+            <a:rect l="l" t="t" r="r" b="b"/>
             <a:pathLst>
-              <a:path h="862755" w="18288000">
+              <a:path w="18288000" h="862755">
                 <a:moveTo>
                   <a:pt x="0" y="0"/>
                 </a:moveTo>
@@ -8327,39 +8001,39 @@
               </a:extLst>
             </a:blip>
             <a:stretch>
-              <a:fillRect l="0" t="0" r="0" b="0"/>
+              <a:fillRect/>
             </a:stretch>
           </a:blipFill>
         </p:spPr>
       </p:sp>
       <p:sp>
         <p:nvSpPr>
-          <p:cNvPr name="TextBox 7" id="7"/>
-          <p:cNvSpPr txBox="true"/>
+          <p:cNvPr id="7" name="TextBox 7"/>
+          <p:cNvSpPr txBox="1"/>
           <p:nvPr/>
         </p:nvSpPr>
         <p:spPr>
-          <a:xfrm rot="0">
+          <a:xfrm>
             <a:off x="6208852" y="9703384"/>
-            <a:ext cx="5346630" cy="453466"/>
+            <a:ext cx="7049948" cy="415370"/>
           </a:xfrm>
           <a:prstGeom prst="rect">
             <a:avLst/>
           </a:prstGeom>
         </p:spPr>
         <p:txBody>
-          <a:bodyPr anchor="t" rtlCol="false" tIns="0" lIns="0" bIns="0" rIns="0">
+          <a:bodyPr wrap="square" lIns="0" tIns="0" rIns="0" bIns="0" rtlCol="0" anchor="t">
             <a:spAutoFit/>
           </a:bodyPr>
           <a:lstStyle/>
           <a:p>
-            <a:pPr algn="l">
+            <a:pPr>
               <a:lnSpc>
                 <a:spcPts val="3499"/>
               </a:lnSpc>
             </a:pPr>
             <a:r>
-              <a:rPr lang="en-US" sz="2700">
+              <a:rPr lang="en-US" sz="2700" dirty="0">
                 <a:solidFill>
                   <a:srgbClr val="FFFFFF"/>
                 </a:solidFill>
@@ -8368,56 +8042,10 @@
                 <a:cs typeface="Cambria"/>
                 <a:sym typeface="Cambria"/>
               </a:rPr>
-              <a:t>SRCAS HACKATHON - 3.0 template</a:t>
-            </a:r>
-          </a:p>
-        </p:txBody>
-      </p:sp>
-      <p:sp>
-        <p:nvSpPr>
-          <p:cNvPr name="Freeform 8" id="8"/>
-          <p:cNvSpPr/>
-          <p:nvPr/>
-        </p:nvSpPr>
-        <p:spPr>
-          <a:xfrm flipH="false" flipV="false" rot="0">
-            <a:off x="14714122" y="342716"/>
-            <a:ext cx="3263458" cy="982059"/>
-          </a:xfrm>
-          <a:custGeom>
-            <a:avLst/>
-            <a:gdLst/>
-            <a:ahLst/>
-            <a:cxnLst/>
-            <a:rect r="r" b="b" t="t" l="l"/>
-            <a:pathLst>
-              <a:path h="982059" w="3263458">
-                <a:moveTo>
-                  <a:pt x="0" y="0"/>
-                </a:moveTo>
-                <a:lnTo>
-                  <a:pt x="3263458" y="0"/>
-                </a:lnTo>
-                <a:lnTo>
-                  <a:pt x="3263458" y="982059"/>
-                </a:lnTo>
-                <a:lnTo>
-                  <a:pt x="0" y="982059"/>
-                </a:lnTo>
-                <a:lnTo>
-                  <a:pt x="0" y="0"/>
-                </a:lnTo>
-                <a:close/>
-              </a:path>
-            </a:pathLst>
-          </a:custGeom>
-          <a:blipFill>
-            <a:blip r:embed="rId6"/>
-            <a:stretch>
-              <a:fillRect l="0" t="0" r="0" b="0"/>
-            </a:stretch>
-          </a:blipFill>
-        </p:spPr>
+              <a:t>HACKATHON - 2027 template</a:t>
+            </a:r>
+          </a:p>
+        </p:txBody>
       </p:sp>
     </p:spTree>
   </p:cSld>

</xml_diff>